<commit_message>
PPTX dla inwestorów: schemat z natywnych, edytowalnych kształtów zamiast obrazka
Co-Authored-By: Claude Opus 5.5 <noreply@anthropic.com>
Claude-Session: https://claude.ai/code/session_016FeHWNVbh7ozKFZPMmBYtd
</commit_message>
<xml_diff>
--- a/GA_Power_GAia_Investors.pptx
+++ b/GA_Power_GAia_Investors.pptx
@@ -979,20 +979,12 @@
           <a:chExt cx="0" cy="0"/>
         </a:xfrm>
       </p:grpSpPr>
-      <p:pic>
-        <p:nvPicPr>
-          <p:cNvPr id="2" name="Picture 1" descr="GA_Power_GAia_Investors.png"/>
-          <p:cNvPicPr>
-            <a:picLocks noChangeAspect="1"/>
-          </p:cNvPicPr>
-          <p:nvPr/>
-        </p:nvPicPr>
-        <p:blipFill>
-          <a:blip r:embed="rId3"/>
-          <a:stretch>
-            <a:fillRect/>
-          </a:stretch>
-        </p:blipFill>
+      <p:sp>
+        <p:nvSpPr>
+          <p:cNvPr id="2" name="Canvas"/>
+          <p:cNvSpPr/>
+          <p:nvPr/>
+        </p:nvSpPr>
         <p:spPr>
           <a:xfrm>
             <a:off x="0" y="0"/>
@@ -1001,8 +993,4464 @@
           <a:prstGeom prst="rect">
             <a:avLst/>
           </a:prstGeom>
-        </p:spPr>
-      </p:pic>
+          <a:solidFill>
+            <a:srgbClr val="FFFFFF"/>
+          </a:solidFill>
+          <a:ln>
+            <a:noFill/>
+          </a:ln>
+          <a:effectLst/>
+        </p:spPr>
+        <p:style>
+          <a:lnRef idx="1">
+            <a:schemeClr val="accent1"/>
+          </a:lnRef>
+          <a:fillRef idx="3">
+            <a:schemeClr val="accent1"/>
+          </a:fillRef>
+          <a:effectRef idx="2">
+            <a:schemeClr val="accent1"/>
+          </a:effectRef>
+          <a:fontRef idx="minor">
+            <a:schemeClr val="lt1"/>
+          </a:fontRef>
+        </p:style>
+        <p:txBody>
+          <a:bodyPr rtlCol="0" anchor="ctr"/>
+          <a:lstStyle/>
+          <a:p>
+            <a:pPr algn="ctr"/>
+          </a:p>
+        </p:txBody>
+      </p:sp>
+      <p:sp>
+        <p:nvSpPr>
+          <p:cNvPr id="3" name="GRUPA AZOTY · INVESTOR VIEW"/>
+          <p:cNvSpPr/>
+          <p:nvPr/>
+        </p:nvSpPr>
+        <p:spPr>
+          <a:xfrm>
+            <a:off x="254000" y="165100"/>
+            <a:ext cx="8255000" cy="139700"/>
+          </a:xfrm>
+          <a:prstGeom prst="rect">
+            <a:avLst/>
+          </a:prstGeom>
+          <a:noFill/>
+          <a:ln>
+            <a:noFill/>
+          </a:ln>
+          <a:effectLst/>
+        </p:spPr>
+        <p:style>
+          <a:lnRef idx="1">
+            <a:schemeClr val="accent1"/>
+          </a:lnRef>
+          <a:fillRef idx="3">
+            <a:schemeClr val="accent1"/>
+          </a:fillRef>
+          <a:effectRef idx="2">
+            <a:schemeClr val="accent1"/>
+          </a:effectRef>
+          <a:fontRef idx="minor">
+            <a:schemeClr val="lt1"/>
+          </a:fontRef>
+        </p:style>
+        <p:txBody>
+          <a:bodyPr rtlCol="0" anchor="ctr" wrap="square" lIns="0" rIns="0" tIns="12700" bIns="12700"/>
+          <a:lstStyle/>
+          <a:p>
+            <a:pPr algn="l">
+              <a:lnSpc>
+                <a:spcPct val="100000"/>
+              </a:lnSpc>
+            </a:pPr>
+            <a:r>
+              <a:rPr sz="700" b="1" spc="150">
+                <a:solidFill>
+                  <a:srgbClr val="1F5F99"/>
+                </a:solidFill>
+                <a:latin typeface="Arial"/>
+              </a:rPr>
+              <a:t>GRUPA AZOTY · INVESTOR VIEW</a:t>
+            </a:r>
+          </a:p>
+        </p:txBody>
+      </p:sp>
+      <p:sp>
+        <p:nvSpPr>
+          <p:cNvPr id="4" name="THE MACHINE IS BUILT. GAia IS ITS BRAIN"/>
+          <p:cNvSpPr/>
+          <p:nvPr/>
+        </p:nvSpPr>
+        <p:spPr>
+          <a:xfrm>
+            <a:off x="254000" y="317500"/>
+            <a:ext cx="8255000" cy="317500"/>
+          </a:xfrm>
+          <a:prstGeom prst="rect">
+            <a:avLst/>
+          </a:prstGeom>
+          <a:noFill/>
+          <a:ln>
+            <a:noFill/>
+          </a:ln>
+          <a:effectLst/>
+        </p:spPr>
+        <p:style>
+          <a:lnRef idx="1">
+            <a:schemeClr val="accent1"/>
+          </a:lnRef>
+          <a:fillRef idx="3">
+            <a:schemeClr val="accent1"/>
+          </a:fillRef>
+          <a:effectRef idx="2">
+            <a:schemeClr val="accent1"/>
+          </a:effectRef>
+          <a:fontRef idx="minor">
+            <a:schemeClr val="lt1"/>
+          </a:fontRef>
+        </p:style>
+        <p:txBody>
+          <a:bodyPr rtlCol="0" anchor="ctr" wrap="square" lIns="0" rIns="0" tIns="12700" bIns="12700"/>
+          <a:lstStyle/>
+          <a:p>
+            <a:pPr algn="l">
+              <a:lnSpc>
+                <a:spcPct val="100000"/>
+              </a:lnSpc>
+            </a:pPr>
+            <a:r>
+              <a:rPr sz="2000" b="1">
+                <a:solidFill>
+                  <a:srgbClr val="183349"/>
+                </a:solidFill>
+                <a:latin typeface="Arial"/>
+              </a:rPr>
+              <a:t>THE MACHINE IS BUILT. GAia IS ITS BRAIN.</a:t>
+            </a:r>
+          </a:p>
+        </p:txBody>
+      </p:sp>
+      <p:sp>
+        <p:nvSpPr>
+          <p:cNvPr id="5" name="Europe's #2 fertilizer group runs the en"/>
+          <p:cNvSpPr/>
+          <p:nvPr/>
+        </p:nvSpPr>
+        <p:spPr>
+          <a:xfrm>
+            <a:off x="254000" y="647700"/>
+            <a:ext cx="8255000" cy="254000"/>
+          </a:xfrm>
+          <a:prstGeom prst="rect">
+            <a:avLst/>
+          </a:prstGeom>
+          <a:noFill/>
+          <a:ln>
+            <a:noFill/>
+          </a:ln>
+          <a:effectLst/>
+        </p:spPr>
+        <p:style>
+          <a:lnRef idx="1">
+            <a:schemeClr val="accent1"/>
+          </a:lnRef>
+          <a:fillRef idx="3">
+            <a:schemeClr val="accent1"/>
+          </a:fillRef>
+          <a:effectRef idx="2">
+            <a:schemeClr val="accent1"/>
+          </a:effectRef>
+          <a:fontRef idx="minor">
+            <a:schemeClr val="lt1"/>
+          </a:fontRef>
+        </p:style>
+        <p:txBody>
+          <a:bodyPr rtlCol="0" anchor="ctr" wrap="square" lIns="0" rIns="0" tIns="12700" bIns="12700"/>
+          <a:lstStyle/>
+          <a:p>
+            <a:pPr algn="l">
+              <a:lnSpc>
+                <a:spcPct val="100000"/>
+              </a:lnSpc>
+            </a:pPr>
+            <a:r>
+              <a:rPr sz="800" b="0">
+                <a:solidFill>
+                  <a:srgbClr val="1E1E1E"/>
+                </a:solidFill>
+                <a:latin typeface="Arial"/>
+              </a:rPr>
+              <a:t>Europe's #2 fertilizer group runs the entire chain itself, from its own raw materials to 68 distributors. </a:t>
+            </a:r>
+            <a:r>
+              <a:rPr sz="800" b="1">
+                <a:solidFill>
+                  <a:srgbClr val="1E1E1E"/>
+                </a:solidFill>
+                <a:latin typeface="Arial"/>
+              </a:rPr>
+              <a:t>The one link it does not own is the farmer's demand data.</a:t>
+            </a:r>
+            <a:r>
+              <a:rPr sz="800" b="0">
+                <a:solidFill>
+                  <a:srgbClr val="1E1E1E"/>
+                </a:solidFill>
+                <a:latin typeface="Arial"/>
+              </a:rPr>
+              <a:t> GAia closes the loop.</a:t>
+            </a:r>
+          </a:p>
+        </p:txBody>
+      </p:sp>
+      <p:sp>
+        <p:nvSpPr>
+          <p:cNvPr id="6" name="THE PRIZE     +PLN 0.78 bn    revenue"/>
+          <p:cNvSpPr/>
+          <p:nvPr/>
+        </p:nvSpPr>
+        <p:spPr>
+          <a:xfrm>
+            <a:off x="8699500" y="165100"/>
+            <a:ext cx="3238500" cy="749300"/>
+          </a:xfrm>
+          <a:prstGeom prst="roundRect">
+            <a:avLst>
+              <a:gd name="adj" fmla="val 8000"/>
+            </a:avLst>
+          </a:prstGeom>
+          <a:solidFill>
+            <a:srgbClr val="1F7A5A"/>
+          </a:solidFill>
+          <a:ln>
+            <a:noFill/>
+          </a:ln>
+          <a:effectLst/>
+        </p:spPr>
+        <p:style>
+          <a:lnRef idx="1">
+            <a:schemeClr val="accent1"/>
+          </a:lnRef>
+          <a:fillRef idx="3">
+            <a:schemeClr val="accent1"/>
+          </a:fillRef>
+          <a:effectRef idx="2">
+            <a:schemeClr val="accent1"/>
+          </a:effectRef>
+          <a:fontRef idx="minor">
+            <a:schemeClr val="lt1"/>
+          </a:fontRef>
+        </p:style>
+        <p:txBody>
+          <a:bodyPr rtlCol="0" anchor="ctr" wrap="square" lIns="114300" rIns="114300" tIns="12700" bIns="12700"/>
+          <a:lstStyle/>
+          <a:p>
+            <a:pPr algn="l">
+              <a:lnSpc>
+                <a:spcPct val="100000"/>
+              </a:lnSpc>
+            </a:pPr>
+            <a:r>
+              <a:rPr sz="600" b="1" spc="100">
+                <a:solidFill>
+                  <a:srgbClr val="BFE6D4"/>
+                </a:solidFill>
+                <a:latin typeface="Arial"/>
+              </a:rPr>
+              <a:t>THE PRIZE</a:t>
+            </a:r>
+          </a:p>
+          <a:p>
+            <a:pPr algn="l">
+              <a:lnSpc>
+                <a:spcPct val="100000"/>
+              </a:lnSpc>
+            </a:pPr>
+            <a:r>
+              <a:rPr sz="1700" b="1">
+                <a:solidFill>
+                  <a:srgbClr val="FFFFFF"/>
+                </a:solidFill>
+                <a:latin typeface="Arial"/>
+              </a:rPr>
+              <a:t>+PLN 0.78 bn</a:t>
+            </a:r>
+            <a:r>
+              <a:rPr sz="750" b="0">
+                <a:solidFill>
+                  <a:srgbClr val="FFFFFF"/>
+                </a:solidFill>
+                <a:latin typeface="Arial"/>
+              </a:rPr>
+              <a:t> revenue / year</a:t>
+            </a:r>
+          </a:p>
+          <a:p>
+            <a:pPr algn="l">
+              <a:lnSpc>
+                <a:spcPct val="100000"/>
+              </a:lnSpc>
+            </a:pPr>
+            <a:r>
+              <a:rPr sz="700" b="0">
+                <a:solidFill>
+                  <a:srgbClr val="FFFFFF"/>
+                </a:solidFill>
+                <a:latin typeface="Arial"/>
+              </a:rPr>
+              <a:t>AN/CAN 45% → 60% · NPK 42% → 60% · 1 p.p. AN/CAN ≈ PLN 39 m</a:t>
+            </a:r>
+          </a:p>
+        </p:txBody>
+      </p:sp>
+      <p:sp>
+        <p:nvSpPr>
+          <p:cNvPr id="7" name="Shape"/>
+          <p:cNvSpPr/>
+          <p:nvPr/>
+        </p:nvSpPr>
+        <p:spPr>
+          <a:xfrm>
+            <a:off x="254000" y="1028700"/>
+            <a:ext cx="11684000" cy="3162300"/>
+          </a:xfrm>
+          <a:prstGeom prst="roundRect">
+            <a:avLst>
+              <a:gd name="adj" fmla="val 2000"/>
+            </a:avLst>
+          </a:prstGeom>
+          <a:solidFill>
+            <a:srgbClr val="F3F4F5"/>
+          </a:solidFill>
+          <a:ln w="9525">
+            <a:solidFill>
+              <a:srgbClr val="D5DBE0"/>
+            </a:solidFill>
+          </a:ln>
+          <a:effectLst/>
+        </p:spPr>
+        <p:style>
+          <a:lnRef idx="1">
+            <a:schemeClr val="accent1"/>
+          </a:lnRef>
+          <a:fillRef idx="3">
+            <a:schemeClr val="accent1"/>
+          </a:fillRef>
+          <a:effectRef idx="2">
+            <a:schemeClr val="accent1"/>
+          </a:effectRef>
+          <a:fontRef idx="minor">
+            <a:schemeClr val="lt1"/>
+          </a:fontRef>
+        </p:style>
+        <p:txBody>
+          <a:bodyPr rtlCol="0" anchor="ctr"/>
+          <a:lstStyle/>
+          <a:p>
+            <a:pPr algn="ctr"/>
+          </a:p>
+        </p:txBody>
+      </p:sp>
+      <p:sp>
+        <p:nvSpPr>
+          <p:cNvPr id="8" name="PHYSICAL VALUE CHAIN &amp;nbsp;&amp;nbsp; built"/>
+          <p:cNvSpPr/>
+          <p:nvPr/>
+        </p:nvSpPr>
+        <p:spPr>
+          <a:xfrm>
+            <a:off x="381000" y="1079500"/>
+            <a:ext cx="7620000" cy="165100"/>
+          </a:xfrm>
+          <a:prstGeom prst="rect">
+            <a:avLst/>
+          </a:prstGeom>
+          <a:noFill/>
+          <a:ln>
+            <a:noFill/>
+          </a:ln>
+          <a:effectLst/>
+        </p:spPr>
+        <p:style>
+          <a:lnRef idx="1">
+            <a:schemeClr val="accent1"/>
+          </a:lnRef>
+          <a:fillRef idx="3">
+            <a:schemeClr val="accent1"/>
+          </a:fillRef>
+          <a:effectRef idx="2">
+            <a:schemeClr val="accent1"/>
+          </a:effectRef>
+          <a:fontRef idx="minor">
+            <a:schemeClr val="lt1"/>
+          </a:fontRef>
+        </p:style>
+        <p:txBody>
+          <a:bodyPr rtlCol="0" anchor="ctr" wrap="square" lIns="0" rIns="0" tIns="12700" bIns="12700"/>
+          <a:lstStyle/>
+          <a:p>
+            <a:pPr algn="l">
+              <a:lnSpc>
+                <a:spcPct val="100000"/>
+              </a:lnSpc>
+            </a:pPr>
+            <a:r>
+              <a:rPr sz="700" b="1" spc="100">
+                <a:solidFill>
+                  <a:srgbClr val="183349"/>
+                </a:solidFill>
+                <a:latin typeface="Arial"/>
+              </a:rPr>
+              <a:t>PHYSICAL VALUE CHAIN</a:t>
+            </a:r>
+            <a:r>
+              <a:rPr sz="700" b="0">
+                <a:solidFill>
+                  <a:srgbClr val="183349"/>
+                </a:solidFill>
+                <a:latin typeface="Arial"/>
+              </a:rPr>
+              <a:t>  </a:t>
+            </a:r>
+            <a:r>
+              <a:rPr sz="700" b="0">
+                <a:solidFill>
+                  <a:srgbClr val="5B6B76"/>
+                </a:solidFill>
+                <a:latin typeface="Arial"/>
+              </a:rPr>
+              <a:t>built · owned · paid for</a:t>
+            </a:r>
+          </a:p>
+        </p:txBody>
+      </p:sp>
+      <p:sp>
+        <p:nvSpPr>
+          <p:cNvPr id="9" name="01 · RAW MATERIALS     S · P · NH₃"/>
+          <p:cNvSpPr/>
+          <p:nvPr/>
+        </p:nvSpPr>
+        <p:spPr>
+          <a:xfrm>
+            <a:off x="381000" y="1295400"/>
+            <a:ext cx="1905000" cy="660400"/>
+          </a:xfrm>
+          <a:prstGeom prst="roundRect">
+            <a:avLst>
+              <a:gd name="adj" fmla="val 6000"/>
+            </a:avLst>
+          </a:prstGeom>
+          <a:solidFill>
+            <a:srgbClr val="183349"/>
+          </a:solidFill>
+          <a:ln>
+            <a:noFill/>
+          </a:ln>
+          <a:effectLst/>
+        </p:spPr>
+        <p:style>
+          <a:lnRef idx="1">
+            <a:schemeClr val="accent1"/>
+          </a:lnRef>
+          <a:fillRef idx="3">
+            <a:schemeClr val="accent1"/>
+          </a:fillRef>
+          <a:effectRef idx="2">
+            <a:schemeClr val="accent1"/>
+          </a:effectRef>
+          <a:fontRef idx="minor">
+            <a:schemeClr val="lt1"/>
+          </a:fontRef>
+        </p:style>
+        <p:txBody>
+          <a:bodyPr rtlCol="0" anchor="ctr" wrap="square" lIns="101600" rIns="101600" tIns="12700" bIns="12700"/>
+          <a:lstStyle/>
+          <a:p>
+            <a:pPr algn="l">
+              <a:lnSpc>
+                <a:spcPct val="100000"/>
+              </a:lnSpc>
+            </a:pPr>
+            <a:r>
+              <a:rPr sz="600" b="1" spc="100">
+                <a:solidFill>
+                  <a:srgbClr val="9FC3E6"/>
+                </a:solidFill>
+                <a:latin typeface="Arial"/>
+              </a:rPr>
+              <a:t>01 · RAW MATERIALS</a:t>
+            </a:r>
+          </a:p>
+          <a:p>
+            <a:pPr algn="l">
+              <a:lnSpc>
+                <a:spcPct val="100000"/>
+              </a:lnSpc>
+            </a:pPr>
+            <a:r>
+              <a:rPr sz="1800" b="1">
+                <a:solidFill>
+                  <a:srgbClr val="FFFFFF"/>
+                </a:solidFill>
+                <a:latin typeface="Arial"/>
+              </a:rPr>
+              <a:t>S · P · NH₃</a:t>
+            </a:r>
+          </a:p>
+          <a:p>
+            <a:pPr algn="l">
+              <a:lnSpc>
+                <a:spcPct val="100000"/>
+              </a:lnSpc>
+            </a:pPr>
+            <a:r>
+              <a:rPr sz="700" b="1">
+                <a:solidFill>
+                  <a:srgbClr val="BFE6D4"/>
+                </a:solidFill>
+                <a:latin typeface="Arial"/>
+              </a:rPr>
+              <a:t>own inputs</a:t>
+            </a:r>
+          </a:p>
+        </p:txBody>
+      </p:sp>
+      <p:sp>
+        <p:nvSpPr>
+          <p:cNvPr id="10" name="Siarkopol   own sulphur mine"/>
+          <p:cNvSpPr/>
+          <p:nvPr/>
+        </p:nvSpPr>
+        <p:spPr>
+          <a:xfrm>
+            <a:off x="381000" y="2070100"/>
+            <a:ext cx="1905000" cy="355600"/>
+          </a:xfrm>
+          <a:prstGeom prst="roundRect">
+            <a:avLst>
+              <a:gd name="adj" fmla="val 10000"/>
+            </a:avLst>
+          </a:prstGeom>
+          <a:solidFill>
+            <a:srgbClr val="FFFFFF"/>
+          </a:solidFill>
+          <a:ln w="9525">
+            <a:solidFill>
+              <a:srgbClr val="C9D2DA"/>
+            </a:solidFill>
+          </a:ln>
+          <a:effectLst/>
+        </p:spPr>
+        <p:style>
+          <a:lnRef idx="1">
+            <a:schemeClr val="accent1"/>
+          </a:lnRef>
+          <a:fillRef idx="3">
+            <a:schemeClr val="accent1"/>
+          </a:fillRef>
+          <a:effectRef idx="2">
+            <a:schemeClr val="accent1"/>
+          </a:effectRef>
+          <a:fontRef idx="minor">
+            <a:schemeClr val="lt1"/>
+          </a:fontRef>
+        </p:style>
+        <p:txBody>
+          <a:bodyPr rtlCol="0" anchor="ctr" wrap="square" lIns="88900" rIns="88900" tIns="12700" bIns="12700"/>
+          <a:lstStyle/>
+          <a:p>
+            <a:pPr algn="l">
+              <a:lnSpc>
+                <a:spcPct val="100000"/>
+              </a:lnSpc>
+            </a:pPr>
+            <a:r>
+              <a:rPr sz="750" b="1">
+                <a:solidFill>
+                  <a:srgbClr val="183349"/>
+                </a:solidFill>
+                <a:latin typeface="Arial"/>
+              </a:rPr>
+              <a:t>Siarkopol</a:t>
+            </a:r>
+          </a:p>
+          <a:p>
+            <a:pPr algn="l">
+              <a:lnSpc>
+                <a:spcPct val="100000"/>
+              </a:lnSpc>
+            </a:pPr>
+            <a:r>
+              <a:rPr sz="650" b="0">
+                <a:solidFill>
+                  <a:srgbClr val="5B6B76"/>
+                </a:solidFill>
+                <a:latin typeface="Arial"/>
+              </a:rPr>
+              <a:t>own sulphur mine</a:t>
+            </a:r>
+          </a:p>
+        </p:txBody>
+      </p:sp>
+      <p:sp>
+        <p:nvSpPr>
+          <p:cNvPr id="11" name="Gdańsk &amp;amp; Police   phosphate proces"/>
+          <p:cNvSpPr/>
+          <p:nvPr/>
+        </p:nvSpPr>
+        <p:spPr>
+          <a:xfrm>
+            <a:off x="381000" y="2476500"/>
+            <a:ext cx="1905000" cy="355600"/>
+          </a:xfrm>
+          <a:prstGeom prst="roundRect">
+            <a:avLst>
+              <a:gd name="adj" fmla="val 10000"/>
+            </a:avLst>
+          </a:prstGeom>
+          <a:solidFill>
+            <a:srgbClr val="FFFFFF"/>
+          </a:solidFill>
+          <a:ln w="9525">
+            <a:solidFill>
+              <a:srgbClr val="C9D2DA"/>
+            </a:solidFill>
+          </a:ln>
+          <a:effectLst/>
+        </p:spPr>
+        <p:style>
+          <a:lnRef idx="1">
+            <a:schemeClr val="accent1"/>
+          </a:lnRef>
+          <a:fillRef idx="3">
+            <a:schemeClr val="accent1"/>
+          </a:fillRef>
+          <a:effectRef idx="2">
+            <a:schemeClr val="accent1"/>
+          </a:effectRef>
+          <a:fontRef idx="minor">
+            <a:schemeClr val="lt1"/>
+          </a:fontRef>
+        </p:style>
+        <p:txBody>
+          <a:bodyPr rtlCol="0" anchor="ctr" wrap="square" lIns="88900" rIns="88900" tIns="12700" bIns="12700"/>
+          <a:lstStyle/>
+          <a:p>
+            <a:pPr algn="l">
+              <a:lnSpc>
+                <a:spcPct val="100000"/>
+              </a:lnSpc>
+            </a:pPr>
+            <a:r>
+              <a:rPr sz="750" b="1">
+                <a:solidFill>
+                  <a:srgbClr val="183349"/>
+                </a:solidFill>
+                <a:latin typeface="Arial"/>
+              </a:rPr>
+              <a:t>Gdańsk &amp; Police</a:t>
+            </a:r>
+          </a:p>
+          <a:p>
+            <a:pPr algn="l">
+              <a:lnSpc>
+                <a:spcPct val="100000"/>
+              </a:lnSpc>
+            </a:pPr>
+            <a:r>
+              <a:rPr sz="650" b="0">
+                <a:solidFill>
+                  <a:srgbClr val="5B6B76"/>
+                </a:solidFill>
+                <a:latin typeface="Arial"/>
+              </a:rPr>
+              <a:t>phosphate processing</a:t>
+            </a:r>
+          </a:p>
+        </p:txBody>
+      </p:sp>
+      <p:sp>
+        <p:nvSpPr>
+          <p:cNvPr id="12" name="Police sea terminal   ammonia import &amp;"/>
+          <p:cNvSpPr/>
+          <p:nvPr/>
+        </p:nvSpPr>
+        <p:spPr>
+          <a:xfrm>
+            <a:off x="381000" y="2882900"/>
+            <a:ext cx="1905000" cy="355600"/>
+          </a:xfrm>
+          <a:prstGeom prst="roundRect">
+            <a:avLst>
+              <a:gd name="adj" fmla="val 10000"/>
+            </a:avLst>
+          </a:prstGeom>
+          <a:solidFill>
+            <a:srgbClr val="FFFFFF"/>
+          </a:solidFill>
+          <a:ln w="9525">
+            <a:solidFill>
+              <a:srgbClr val="C9D2DA"/>
+            </a:solidFill>
+          </a:ln>
+          <a:effectLst/>
+        </p:spPr>
+        <p:style>
+          <a:lnRef idx="1">
+            <a:schemeClr val="accent1"/>
+          </a:lnRef>
+          <a:fillRef idx="3">
+            <a:schemeClr val="accent1"/>
+          </a:fillRef>
+          <a:effectRef idx="2">
+            <a:schemeClr val="accent1"/>
+          </a:effectRef>
+          <a:fontRef idx="minor">
+            <a:schemeClr val="lt1"/>
+          </a:fontRef>
+        </p:style>
+        <p:txBody>
+          <a:bodyPr rtlCol="0" anchor="ctr" wrap="square" lIns="88900" rIns="88900" tIns="12700" bIns="12700"/>
+          <a:lstStyle/>
+          <a:p>
+            <a:pPr algn="l">
+              <a:lnSpc>
+                <a:spcPct val="100000"/>
+              </a:lnSpc>
+            </a:pPr>
+            <a:r>
+              <a:rPr sz="750" b="1">
+                <a:solidFill>
+                  <a:srgbClr val="183349"/>
+                </a:solidFill>
+                <a:latin typeface="Arial"/>
+              </a:rPr>
+              <a:t>Police sea terminal</a:t>
+            </a:r>
+          </a:p>
+          <a:p>
+            <a:pPr algn="l">
+              <a:lnSpc>
+                <a:spcPct val="100000"/>
+              </a:lnSpc>
+            </a:pPr>
+            <a:r>
+              <a:rPr sz="650" b="0">
+                <a:solidFill>
+                  <a:srgbClr val="5B6B76"/>
+                </a:solidFill>
+                <a:latin typeface="Arial"/>
+              </a:rPr>
+              <a:t>ammonia import &amp; storage</a:t>
+            </a:r>
+          </a:p>
+        </p:txBody>
+      </p:sp>
+      <p:sp>
+        <p:nvSpPr>
+          <p:cNvPr id="13" name="Gas &amp;amp; energy   one shared Group ba"/>
+          <p:cNvSpPr/>
+          <p:nvPr/>
+        </p:nvSpPr>
+        <p:spPr>
+          <a:xfrm>
+            <a:off x="381000" y="3289300"/>
+            <a:ext cx="1905000" cy="355600"/>
+          </a:xfrm>
+          <a:prstGeom prst="roundRect">
+            <a:avLst>
+              <a:gd name="adj" fmla="val 10000"/>
+            </a:avLst>
+          </a:prstGeom>
+          <a:solidFill>
+            <a:srgbClr val="FFFFFF"/>
+          </a:solidFill>
+          <a:ln w="9525">
+            <a:solidFill>
+              <a:srgbClr val="C9D2DA"/>
+            </a:solidFill>
+          </a:ln>
+          <a:effectLst/>
+        </p:spPr>
+        <p:style>
+          <a:lnRef idx="1">
+            <a:schemeClr val="accent1"/>
+          </a:lnRef>
+          <a:fillRef idx="3">
+            <a:schemeClr val="accent1"/>
+          </a:fillRef>
+          <a:effectRef idx="2">
+            <a:schemeClr val="accent1"/>
+          </a:effectRef>
+          <a:fontRef idx="minor">
+            <a:schemeClr val="lt1"/>
+          </a:fontRef>
+        </p:style>
+        <p:txBody>
+          <a:bodyPr rtlCol="0" anchor="ctr" wrap="square" lIns="88900" rIns="88900" tIns="12700" bIns="12700"/>
+          <a:lstStyle/>
+          <a:p>
+            <a:pPr algn="l">
+              <a:lnSpc>
+                <a:spcPct val="100000"/>
+              </a:lnSpc>
+            </a:pPr>
+            <a:r>
+              <a:rPr sz="750" b="1">
+                <a:solidFill>
+                  <a:srgbClr val="183349"/>
+                </a:solidFill>
+                <a:latin typeface="Arial"/>
+              </a:rPr>
+              <a:t>Gas &amp; energy</a:t>
+            </a:r>
+          </a:p>
+          <a:p>
+            <a:pPr algn="l">
+              <a:lnSpc>
+                <a:spcPct val="100000"/>
+              </a:lnSpc>
+            </a:pPr>
+            <a:r>
+              <a:rPr sz="650" b="0">
+                <a:solidFill>
+                  <a:srgbClr val="5B6B76"/>
+                </a:solidFill>
+                <a:latin typeface="Arial"/>
+              </a:rPr>
+              <a:t>one shared Group base</a:t>
+            </a:r>
+          </a:p>
+        </p:txBody>
+      </p:sp>
+      <p:sp>
+        <p:nvSpPr>
+          <p:cNvPr id="14" name="02 · PRODUCTION     8.76 Mt     per y"/>
+          <p:cNvSpPr/>
+          <p:nvPr/>
+        </p:nvSpPr>
+        <p:spPr>
+          <a:xfrm>
+            <a:off x="2762250" y="1295400"/>
+            <a:ext cx="1905000" cy="660400"/>
+          </a:xfrm>
+          <a:prstGeom prst="roundRect">
+            <a:avLst>
+              <a:gd name="adj" fmla="val 6000"/>
+            </a:avLst>
+          </a:prstGeom>
+          <a:solidFill>
+            <a:srgbClr val="183349"/>
+          </a:solidFill>
+          <a:ln>
+            <a:noFill/>
+          </a:ln>
+          <a:effectLst/>
+        </p:spPr>
+        <p:style>
+          <a:lnRef idx="1">
+            <a:schemeClr val="accent1"/>
+          </a:lnRef>
+          <a:fillRef idx="3">
+            <a:schemeClr val="accent1"/>
+          </a:fillRef>
+          <a:effectRef idx="2">
+            <a:schemeClr val="accent1"/>
+          </a:effectRef>
+          <a:fontRef idx="minor">
+            <a:schemeClr val="lt1"/>
+          </a:fontRef>
+        </p:style>
+        <p:txBody>
+          <a:bodyPr rtlCol="0" anchor="ctr" wrap="square" lIns="101600" rIns="101600" tIns="12700" bIns="12700"/>
+          <a:lstStyle/>
+          <a:p>
+            <a:pPr algn="l">
+              <a:lnSpc>
+                <a:spcPct val="100000"/>
+              </a:lnSpc>
+            </a:pPr>
+            <a:r>
+              <a:rPr sz="600" b="1" spc="100">
+                <a:solidFill>
+                  <a:srgbClr val="9FC3E6"/>
+                </a:solidFill>
+                <a:latin typeface="Arial"/>
+              </a:rPr>
+              <a:t>02 · PRODUCTION</a:t>
+            </a:r>
+          </a:p>
+          <a:p>
+            <a:pPr algn="l">
+              <a:lnSpc>
+                <a:spcPct val="100000"/>
+              </a:lnSpc>
+            </a:pPr>
+            <a:r>
+              <a:rPr sz="1800" b="1">
+                <a:solidFill>
+                  <a:srgbClr val="FFFFFF"/>
+                </a:solidFill>
+                <a:latin typeface="Arial"/>
+              </a:rPr>
+              <a:t>8.76 Mt</a:t>
+            </a:r>
+          </a:p>
+          <a:p>
+            <a:pPr algn="l">
+              <a:lnSpc>
+                <a:spcPct val="100000"/>
+              </a:lnSpc>
+            </a:pPr>
+            <a:r>
+              <a:rPr sz="700" b="1">
+                <a:solidFill>
+                  <a:srgbClr val="BFE6D4"/>
+                </a:solidFill>
+                <a:latin typeface="Arial"/>
+              </a:rPr>
+              <a:t>per year · #2 in EU</a:t>
+            </a:r>
+          </a:p>
+        </p:txBody>
+      </p:sp>
+      <p:sp>
+        <p:nvSpPr>
+          <p:cNvPr id="15" name="Puławy   nitrogen · AN/CAN · urea"/>
+          <p:cNvSpPr/>
+          <p:nvPr/>
+        </p:nvSpPr>
+        <p:spPr>
+          <a:xfrm>
+            <a:off x="2762250" y="2070100"/>
+            <a:ext cx="1905000" cy="355600"/>
+          </a:xfrm>
+          <a:prstGeom prst="roundRect">
+            <a:avLst>
+              <a:gd name="adj" fmla="val 10000"/>
+            </a:avLst>
+          </a:prstGeom>
+          <a:solidFill>
+            <a:srgbClr val="FFFFFF"/>
+          </a:solidFill>
+          <a:ln w="9525">
+            <a:solidFill>
+              <a:srgbClr val="C9D2DA"/>
+            </a:solidFill>
+          </a:ln>
+          <a:effectLst/>
+        </p:spPr>
+        <p:style>
+          <a:lnRef idx="1">
+            <a:schemeClr val="accent1"/>
+          </a:lnRef>
+          <a:fillRef idx="3">
+            <a:schemeClr val="accent1"/>
+          </a:fillRef>
+          <a:effectRef idx="2">
+            <a:schemeClr val="accent1"/>
+          </a:effectRef>
+          <a:fontRef idx="minor">
+            <a:schemeClr val="lt1"/>
+          </a:fontRef>
+        </p:style>
+        <p:txBody>
+          <a:bodyPr rtlCol="0" anchor="ctr" wrap="square" lIns="88900" rIns="88900" tIns="12700" bIns="12700"/>
+          <a:lstStyle/>
+          <a:p>
+            <a:pPr algn="l">
+              <a:lnSpc>
+                <a:spcPct val="100000"/>
+              </a:lnSpc>
+            </a:pPr>
+            <a:r>
+              <a:rPr sz="750" b="1">
+                <a:solidFill>
+                  <a:srgbClr val="183349"/>
+                </a:solidFill>
+                <a:latin typeface="Arial"/>
+              </a:rPr>
+              <a:t>Puławy</a:t>
+            </a:r>
+          </a:p>
+          <a:p>
+            <a:pPr algn="l">
+              <a:lnSpc>
+                <a:spcPct val="100000"/>
+              </a:lnSpc>
+            </a:pPr>
+            <a:r>
+              <a:rPr sz="650" b="0">
+                <a:solidFill>
+                  <a:srgbClr val="5B6B76"/>
+                </a:solidFill>
+                <a:latin typeface="Arial"/>
+              </a:rPr>
+              <a:t>nitrogen · AN/CAN · urea</a:t>
+            </a:r>
+          </a:p>
+        </p:txBody>
+      </p:sp>
+      <p:sp>
+        <p:nvSpPr>
+          <p:cNvPr id="16" name="Police   compound NPK · urea"/>
+          <p:cNvSpPr/>
+          <p:nvPr/>
+        </p:nvSpPr>
+        <p:spPr>
+          <a:xfrm>
+            <a:off x="2762250" y="2476500"/>
+            <a:ext cx="1905000" cy="355600"/>
+          </a:xfrm>
+          <a:prstGeom prst="roundRect">
+            <a:avLst>
+              <a:gd name="adj" fmla="val 10000"/>
+            </a:avLst>
+          </a:prstGeom>
+          <a:solidFill>
+            <a:srgbClr val="FFFFFF"/>
+          </a:solidFill>
+          <a:ln w="9525">
+            <a:solidFill>
+              <a:srgbClr val="C9D2DA"/>
+            </a:solidFill>
+          </a:ln>
+          <a:effectLst/>
+        </p:spPr>
+        <p:style>
+          <a:lnRef idx="1">
+            <a:schemeClr val="accent1"/>
+          </a:lnRef>
+          <a:fillRef idx="3">
+            <a:schemeClr val="accent1"/>
+          </a:fillRef>
+          <a:effectRef idx="2">
+            <a:schemeClr val="accent1"/>
+          </a:effectRef>
+          <a:fontRef idx="minor">
+            <a:schemeClr val="lt1"/>
+          </a:fontRef>
+        </p:style>
+        <p:txBody>
+          <a:bodyPr rtlCol="0" anchor="ctr" wrap="square" lIns="88900" rIns="88900" tIns="12700" bIns="12700"/>
+          <a:lstStyle/>
+          <a:p>
+            <a:pPr algn="l">
+              <a:lnSpc>
+                <a:spcPct val="100000"/>
+              </a:lnSpc>
+            </a:pPr>
+            <a:r>
+              <a:rPr sz="750" b="1">
+                <a:solidFill>
+                  <a:srgbClr val="183349"/>
+                </a:solidFill>
+                <a:latin typeface="Arial"/>
+              </a:rPr>
+              <a:t>Police</a:t>
+            </a:r>
+          </a:p>
+          <a:p>
+            <a:pPr algn="l">
+              <a:lnSpc>
+                <a:spcPct val="100000"/>
+              </a:lnSpc>
+            </a:pPr>
+            <a:r>
+              <a:rPr sz="650" b="0">
+                <a:solidFill>
+                  <a:srgbClr val="5B6B76"/>
+                </a:solidFill>
+                <a:latin typeface="Arial"/>
+              </a:rPr>
+              <a:t>compound NPK · urea</a:t>
+            </a:r>
+          </a:p>
+        </p:txBody>
+      </p:sp>
+      <p:sp>
+        <p:nvSpPr>
+          <p:cNvPr id="17" name="Kędzierzyn   nitrogen · NPK"/>
+          <p:cNvSpPr/>
+          <p:nvPr/>
+        </p:nvSpPr>
+        <p:spPr>
+          <a:xfrm>
+            <a:off x="2762250" y="2882900"/>
+            <a:ext cx="1905000" cy="355600"/>
+          </a:xfrm>
+          <a:prstGeom prst="roundRect">
+            <a:avLst>
+              <a:gd name="adj" fmla="val 10000"/>
+            </a:avLst>
+          </a:prstGeom>
+          <a:solidFill>
+            <a:srgbClr val="FFFFFF"/>
+          </a:solidFill>
+          <a:ln w="9525">
+            <a:solidFill>
+              <a:srgbClr val="C9D2DA"/>
+            </a:solidFill>
+          </a:ln>
+          <a:effectLst/>
+        </p:spPr>
+        <p:style>
+          <a:lnRef idx="1">
+            <a:schemeClr val="accent1"/>
+          </a:lnRef>
+          <a:fillRef idx="3">
+            <a:schemeClr val="accent1"/>
+          </a:fillRef>
+          <a:effectRef idx="2">
+            <a:schemeClr val="accent1"/>
+          </a:effectRef>
+          <a:fontRef idx="minor">
+            <a:schemeClr val="lt1"/>
+          </a:fontRef>
+        </p:style>
+        <p:txBody>
+          <a:bodyPr rtlCol="0" anchor="ctr" wrap="square" lIns="88900" rIns="88900" tIns="12700" bIns="12700"/>
+          <a:lstStyle/>
+          <a:p>
+            <a:pPr algn="l">
+              <a:lnSpc>
+                <a:spcPct val="100000"/>
+              </a:lnSpc>
+            </a:pPr>
+            <a:r>
+              <a:rPr sz="750" b="1">
+                <a:solidFill>
+                  <a:srgbClr val="183349"/>
+                </a:solidFill>
+                <a:latin typeface="Arial"/>
+              </a:rPr>
+              <a:t>Kędzierzyn</a:t>
+            </a:r>
+          </a:p>
+          <a:p>
+            <a:pPr algn="l">
+              <a:lnSpc>
+                <a:spcPct val="100000"/>
+              </a:lnSpc>
+            </a:pPr>
+            <a:r>
+              <a:rPr sz="650" b="0">
+                <a:solidFill>
+                  <a:srgbClr val="5B6B76"/>
+                </a:solidFill>
+                <a:latin typeface="Arial"/>
+              </a:rPr>
+              <a:t>nitrogen · NPK</a:t>
+            </a:r>
+          </a:p>
+        </p:txBody>
+      </p:sp>
+      <p:sp>
+        <p:nvSpPr>
+          <p:cNvPr id="18" name="Tarnów   nitrogen · AN/CAN"/>
+          <p:cNvSpPr/>
+          <p:nvPr/>
+        </p:nvSpPr>
+        <p:spPr>
+          <a:xfrm>
+            <a:off x="2762250" y="3289300"/>
+            <a:ext cx="1905000" cy="355600"/>
+          </a:xfrm>
+          <a:prstGeom prst="roundRect">
+            <a:avLst>
+              <a:gd name="adj" fmla="val 10000"/>
+            </a:avLst>
+          </a:prstGeom>
+          <a:solidFill>
+            <a:srgbClr val="FFFFFF"/>
+          </a:solidFill>
+          <a:ln w="9525">
+            <a:solidFill>
+              <a:srgbClr val="C9D2DA"/>
+            </a:solidFill>
+          </a:ln>
+          <a:effectLst/>
+        </p:spPr>
+        <p:style>
+          <a:lnRef idx="1">
+            <a:schemeClr val="accent1"/>
+          </a:lnRef>
+          <a:fillRef idx="3">
+            <a:schemeClr val="accent1"/>
+          </a:fillRef>
+          <a:effectRef idx="2">
+            <a:schemeClr val="accent1"/>
+          </a:effectRef>
+          <a:fontRef idx="minor">
+            <a:schemeClr val="lt1"/>
+          </a:fontRef>
+        </p:style>
+        <p:txBody>
+          <a:bodyPr rtlCol="0" anchor="ctr" wrap="square" lIns="88900" rIns="88900" tIns="12700" bIns="12700"/>
+          <a:lstStyle/>
+          <a:p>
+            <a:pPr algn="l">
+              <a:lnSpc>
+                <a:spcPct val="100000"/>
+              </a:lnSpc>
+            </a:pPr>
+            <a:r>
+              <a:rPr sz="750" b="1">
+                <a:solidFill>
+                  <a:srgbClr val="183349"/>
+                </a:solidFill>
+                <a:latin typeface="Arial"/>
+              </a:rPr>
+              <a:t>Tarnów</a:t>
+            </a:r>
+          </a:p>
+          <a:p>
+            <a:pPr algn="l">
+              <a:lnSpc>
+                <a:spcPct val="100000"/>
+              </a:lnSpc>
+            </a:pPr>
+            <a:r>
+              <a:rPr sz="650" b="0">
+                <a:solidFill>
+                  <a:srgbClr val="5B6B76"/>
+                </a:solidFill>
+                <a:latin typeface="Arial"/>
+              </a:rPr>
+              <a:t>nitrogen · AN/CAN</a:t>
+            </a:r>
+          </a:p>
+        </p:txBody>
+      </p:sp>
+      <p:sp>
+        <p:nvSpPr>
+          <p:cNvPr id="19" name="Gdańsk   phosphates"/>
+          <p:cNvSpPr/>
+          <p:nvPr/>
+        </p:nvSpPr>
+        <p:spPr>
+          <a:xfrm>
+            <a:off x="2762250" y="3695700"/>
+            <a:ext cx="1905000" cy="355600"/>
+          </a:xfrm>
+          <a:prstGeom prst="roundRect">
+            <a:avLst>
+              <a:gd name="adj" fmla="val 10000"/>
+            </a:avLst>
+          </a:prstGeom>
+          <a:solidFill>
+            <a:srgbClr val="FFFFFF"/>
+          </a:solidFill>
+          <a:ln w="9525">
+            <a:solidFill>
+              <a:srgbClr val="C9D2DA"/>
+            </a:solidFill>
+          </a:ln>
+          <a:effectLst/>
+        </p:spPr>
+        <p:style>
+          <a:lnRef idx="1">
+            <a:schemeClr val="accent1"/>
+          </a:lnRef>
+          <a:fillRef idx="3">
+            <a:schemeClr val="accent1"/>
+          </a:fillRef>
+          <a:effectRef idx="2">
+            <a:schemeClr val="accent1"/>
+          </a:effectRef>
+          <a:fontRef idx="minor">
+            <a:schemeClr val="lt1"/>
+          </a:fontRef>
+        </p:style>
+        <p:txBody>
+          <a:bodyPr rtlCol="0" anchor="ctr" wrap="square" lIns="88900" rIns="88900" tIns="12700" bIns="12700"/>
+          <a:lstStyle/>
+          <a:p>
+            <a:pPr algn="l">
+              <a:lnSpc>
+                <a:spcPct val="100000"/>
+              </a:lnSpc>
+            </a:pPr>
+            <a:r>
+              <a:rPr sz="750" b="1">
+                <a:solidFill>
+                  <a:srgbClr val="183349"/>
+                </a:solidFill>
+                <a:latin typeface="Arial"/>
+              </a:rPr>
+              <a:t>Gdańsk</a:t>
+            </a:r>
+          </a:p>
+          <a:p>
+            <a:pPr algn="l">
+              <a:lnSpc>
+                <a:spcPct val="100000"/>
+              </a:lnSpc>
+            </a:pPr>
+            <a:r>
+              <a:rPr sz="650" b="0">
+                <a:solidFill>
+                  <a:srgbClr val="5B6B76"/>
+                </a:solidFill>
+                <a:latin typeface="Arial"/>
+              </a:rPr>
+              <a:t>phosphates</a:t>
+            </a:r>
+          </a:p>
+        </p:txBody>
+      </p:sp>
+      <p:sp>
+        <p:nvSpPr>
+          <p:cNvPr id="20" name="03 · STORAGE &amp;amp; PACKING     ~240 k"/>
+          <p:cNvSpPr/>
+          <p:nvPr/>
+        </p:nvSpPr>
+        <p:spPr>
+          <a:xfrm>
+            <a:off x="5143500" y="1295400"/>
+            <a:ext cx="1905000" cy="660400"/>
+          </a:xfrm>
+          <a:prstGeom prst="roundRect">
+            <a:avLst>
+              <a:gd name="adj" fmla="val 6000"/>
+            </a:avLst>
+          </a:prstGeom>
+          <a:solidFill>
+            <a:srgbClr val="183349"/>
+          </a:solidFill>
+          <a:ln>
+            <a:noFill/>
+          </a:ln>
+          <a:effectLst/>
+        </p:spPr>
+        <p:style>
+          <a:lnRef idx="1">
+            <a:schemeClr val="accent1"/>
+          </a:lnRef>
+          <a:fillRef idx="3">
+            <a:schemeClr val="accent1"/>
+          </a:fillRef>
+          <a:effectRef idx="2">
+            <a:schemeClr val="accent1"/>
+          </a:effectRef>
+          <a:fontRef idx="minor">
+            <a:schemeClr val="lt1"/>
+          </a:fontRef>
+        </p:style>
+        <p:txBody>
+          <a:bodyPr rtlCol="0" anchor="ctr" wrap="square" lIns="101600" rIns="101600" tIns="12700" bIns="12700"/>
+          <a:lstStyle/>
+          <a:p>
+            <a:pPr algn="l">
+              <a:lnSpc>
+                <a:spcPct val="100000"/>
+              </a:lnSpc>
+            </a:pPr>
+            <a:r>
+              <a:rPr sz="600" b="1" spc="100">
+                <a:solidFill>
+                  <a:srgbClr val="9FC3E6"/>
+                </a:solidFill>
+                <a:latin typeface="Arial"/>
+              </a:rPr>
+              <a:t>03 · STORAGE &amp; PACKING</a:t>
+            </a:r>
+          </a:p>
+          <a:p>
+            <a:pPr algn="l">
+              <a:lnSpc>
+                <a:spcPct val="100000"/>
+              </a:lnSpc>
+            </a:pPr>
+            <a:r>
+              <a:rPr sz="1800" b="1">
+                <a:solidFill>
+                  <a:srgbClr val="FFFFFF"/>
+                </a:solidFill>
+                <a:latin typeface="Arial"/>
+              </a:rPr>
+              <a:t>~240 kt</a:t>
+            </a:r>
+          </a:p>
+          <a:p>
+            <a:pPr algn="l">
+              <a:lnSpc>
+                <a:spcPct val="100000"/>
+              </a:lnSpc>
+            </a:pPr>
+            <a:r>
+              <a:rPr sz="700" b="1">
+                <a:solidFill>
+                  <a:srgbClr val="BFE6D4"/>
+                </a:solidFill>
+                <a:latin typeface="Arial"/>
+              </a:rPr>
+              <a:t>warehouse capacity</a:t>
+            </a:r>
+          </a:p>
+        </p:txBody>
+      </p:sp>
+      <p:sp>
+        <p:nvSpPr>
+          <p:cNvPr id="21" name="Solid fertilizers   ~240 kt in 4 plant"/>
+          <p:cNvSpPr/>
+          <p:nvPr/>
+        </p:nvSpPr>
+        <p:spPr>
+          <a:xfrm>
+            <a:off x="5143500" y="2070100"/>
+            <a:ext cx="1905000" cy="355600"/>
+          </a:xfrm>
+          <a:prstGeom prst="roundRect">
+            <a:avLst>
+              <a:gd name="adj" fmla="val 10000"/>
+            </a:avLst>
+          </a:prstGeom>
+          <a:solidFill>
+            <a:srgbClr val="FFFFFF"/>
+          </a:solidFill>
+          <a:ln w="9525">
+            <a:solidFill>
+              <a:srgbClr val="C9D2DA"/>
+            </a:solidFill>
+          </a:ln>
+          <a:effectLst/>
+        </p:spPr>
+        <p:style>
+          <a:lnRef idx="1">
+            <a:schemeClr val="accent1"/>
+          </a:lnRef>
+          <a:fillRef idx="3">
+            <a:schemeClr val="accent1"/>
+          </a:fillRef>
+          <a:effectRef idx="2">
+            <a:schemeClr val="accent1"/>
+          </a:effectRef>
+          <a:fontRef idx="minor">
+            <a:schemeClr val="lt1"/>
+          </a:fontRef>
+        </p:style>
+        <p:txBody>
+          <a:bodyPr rtlCol="0" anchor="ctr" wrap="square" lIns="88900" rIns="88900" tIns="12700" bIns="12700"/>
+          <a:lstStyle/>
+          <a:p>
+            <a:pPr algn="l">
+              <a:lnSpc>
+                <a:spcPct val="100000"/>
+              </a:lnSpc>
+            </a:pPr>
+            <a:r>
+              <a:rPr sz="750" b="1">
+                <a:solidFill>
+                  <a:srgbClr val="183349"/>
+                </a:solidFill>
+                <a:latin typeface="Arial"/>
+              </a:rPr>
+              <a:t>Solid fertilizers</a:t>
+            </a:r>
+          </a:p>
+          <a:p>
+            <a:pPr algn="l">
+              <a:lnSpc>
+                <a:spcPct val="100000"/>
+              </a:lnSpc>
+            </a:pPr>
+            <a:r>
+              <a:rPr sz="650" b="0">
+                <a:solidFill>
+                  <a:srgbClr val="5B6B76"/>
+                </a:solidFill>
+                <a:latin typeface="Arial"/>
+              </a:rPr>
+              <a:t>~240 kt in 4 plants</a:t>
+            </a:r>
+          </a:p>
+        </p:txBody>
+      </p:sp>
+      <p:sp>
+        <p:nvSpPr>
+          <p:cNvPr id="22" name="Liquid (RSM)   ~40 kt tank capacity"/>
+          <p:cNvSpPr/>
+          <p:nvPr/>
+        </p:nvSpPr>
+        <p:spPr>
+          <a:xfrm>
+            <a:off x="5143500" y="2476500"/>
+            <a:ext cx="1905000" cy="355600"/>
+          </a:xfrm>
+          <a:prstGeom prst="roundRect">
+            <a:avLst>
+              <a:gd name="adj" fmla="val 10000"/>
+            </a:avLst>
+          </a:prstGeom>
+          <a:solidFill>
+            <a:srgbClr val="FFFFFF"/>
+          </a:solidFill>
+          <a:ln w="9525">
+            <a:solidFill>
+              <a:srgbClr val="C9D2DA"/>
+            </a:solidFill>
+          </a:ln>
+          <a:effectLst/>
+        </p:spPr>
+        <p:style>
+          <a:lnRef idx="1">
+            <a:schemeClr val="accent1"/>
+          </a:lnRef>
+          <a:fillRef idx="3">
+            <a:schemeClr val="accent1"/>
+          </a:fillRef>
+          <a:effectRef idx="2">
+            <a:schemeClr val="accent1"/>
+          </a:effectRef>
+          <a:fontRef idx="minor">
+            <a:schemeClr val="lt1"/>
+          </a:fontRef>
+        </p:style>
+        <p:txBody>
+          <a:bodyPr rtlCol="0" anchor="ctr" wrap="square" lIns="88900" rIns="88900" tIns="12700" bIns="12700"/>
+          <a:lstStyle/>
+          <a:p>
+            <a:pPr algn="l">
+              <a:lnSpc>
+                <a:spcPct val="100000"/>
+              </a:lnSpc>
+            </a:pPr>
+            <a:r>
+              <a:rPr sz="750" b="1">
+                <a:solidFill>
+                  <a:srgbClr val="183349"/>
+                </a:solidFill>
+                <a:latin typeface="Arial"/>
+              </a:rPr>
+              <a:t>Liquid (RSM)</a:t>
+            </a:r>
+          </a:p>
+          <a:p>
+            <a:pPr algn="l">
+              <a:lnSpc>
+                <a:spcPct val="100000"/>
+              </a:lnSpc>
+            </a:pPr>
+            <a:r>
+              <a:rPr sz="650" b="0">
+                <a:solidFill>
+                  <a:srgbClr val="5B6B76"/>
+                </a:solidFill>
+                <a:latin typeface="Arial"/>
+              </a:rPr>
+              <a:t>~40 kt tank capacity</a:t>
+            </a:r>
+          </a:p>
+        </p:txBody>
+      </p:sp>
+      <p:sp>
+        <p:nvSpPr>
+          <p:cNvPr id="23" name="Automated palletising   Puławy 1,500 t"/>
+          <p:cNvSpPr/>
+          <p:nvPr/>
+        </p:nvSpPr>
+        <p:spPr>
+          <a:xfrm>
+            <a:off x="5143500" y="2882900"/>
+            <a:ext cx="1905000" cy="355600"/>
+          </a:xfrm>
+          <a:prstGeom prst="roundRect">
+            <a:avLst>
+              <a:gd name="adj" fmla="val 10000"/>
+            </a:avLst>
+          </a:prstGeom>
+          <a:solidFill>
+            <a:srgbClr val="FFFFFF"/>
+          </a:solidFill>
+          <a:ln w="9525">
+            <a:solidFill>
+              <a:srgbClr val="C9D2DA"/>
+            </a:solidFill>
+          </a:ln>
+          <a:effectLst/>
+        </p:spPr>
+        <p:style>
+          <a:lnRef idx="1">
+            <a:schemeClr val="accent1"/>
+          </a:lnRef>
+          <a:fillRef idx="3">
+            <a:schemeClr val="accent1"/>
+          </a:fillRef>
+          <a:effectRef idx="2">
+            <a:schemeClr val="accent1"/>
+          </a:effectRef>
+          <a:fontRef idx="minor">
+            <a:schemeClr val="lt1"/>
+          </a:fontRef>
+        </p:style>
+        <p:txBody>
+          <a:bodyPr rtlCol="0" anchor="ctr" wrap="square" lIns="88900" rIns="88900" tIns="12700" bIns="12700"/>
+          <a:lstStyle/>
+          <a:p>
+            <a:pPr algn="l">
+              <a:lnSpc>
+                <a:spcPct val="100000"/>
+              </a:lnSpc>
+            </a:pPr>
+            <a:r>
+              <a:rPr sz="750" b="1">
+                <a:solidFill>
+                  <a:srgbClr val="183349"/>
+                </a:solidFill>
+                <a:latin typeface="Arial"/>
+              </a:rPr>
+              <a:t>Automated palletising</a:t>
+            </a:r>
+          </a:p>
+          <a:p>
+            <a:pPr algn="l">
+              <a:lnSpc>
+                <a:spcPct val="100000"/>
+              </a:lnSpc>
+            </a:pPr>
+            <a:r>
+              <a:rPr sz="650" b="0">
+                <a:solidFill>
+                  <a:srgbClr val="5B6B76"/>
+                </a:solidFill>
+                <a:latin typeface="Arial"/>
+              </a:rPr>
+              <a:t>Puławy 1,500 t/d · Tarnów 600 t/d</a:t>
+            </a:r>
+          </a:p>
+        </p:txBody>
+      </p:sp>
+      <p:sp>
+        <p:nvSpPr>
+          <p:cNvPr id="24" name="Police · Kędzierzyn   automated lines"/>
+          <p:cNvSpPr/>
+          <p:nvPr/>
+        </p:nvSpPr>
+        <p:spPr>
+          <a:xfrm>
+            <a:off x="5143500" y="3289300"/>
+            <a:ext cx="1905000" cy="355600"/>
+          </a:xfrm>
+          <a:prstGeom prst="roundRect">
+            <a:avLst>
+              <a:gd name="adj" fmla="val 10000"/>
+            </a:avLst>
+          </a:prstGeom>
+          <a:solidFill>
+            <a:srgbClr val="FFFFFF"/>
+          </a:solidFill>
+          <a:ln w="9525">
+            <a:solidFill>
+              <a:srgbClr val="C9D2DA"/>
+            </a:solidFill>
+          </a:ln>
+          <a:effectLst/>
+        </p:spPr>
+        <p:style>
+          <a:lnRef idx="1">
+            <a:schemeClr val="accent1"/>
+          </a:lnRef>
+          <a:fillRef idx="3">
+            <a:schemeClr val="accent1"/>
+          </a:fillRef>
+          <a:effectRef idx="2">
+            <a:schemeClr val="accent1"/>
+          </a:effectRef>
+          <a:fontRef idx="minor">
+            <a:schemeClr val="lt1"/>
+          </a:fontRef>
+        </p:style>
+        <p:txBody>
+          <a:bodyPr rtlCol="0" anchor="ctr" wrap="square" lIns="88900" rIns="88900" tIns="12700" bIns="12700"/>
+          <a:lstStyle/>
+          <a:p>
+            <a:pPr algn="l">
+              <a:lnSpc>
+                <a:spcPct val="100000"/>
+              </a:lnSpc>
+            </a:pPr>
+            <a:r>
+              <a:rPr sz="750" b="1">
+                <a:solidFill>
+                  <a:srgbClr val="183349"/>
+                </a:solidFill>
+                <a:latin typeface="Arial"/>
+              </a:rPr>
+              <a:t>Police · Kędzierzyn</a:t>
+            </a:r>
+          </a:p>
+          <a:p>
+            <a:pPr algn="l">
+              <a:lnSpc>
+                <a:spcPct val="100000"/>
+              </a:lnSpc>
+            </a:pPr>
+            <a:r>
+              <a:rPr sz="650" b="0">
+                <a:solidFill>
+                  <a:srgbClr val="5B6B76"/>
+                </a:solidFill>
+                <a:latin typeface="Arial"/>
+              </a:rPr>
+              <a:t>automated lines</a:t>
+            </a:r>
+          </a:p>
+        </p:txBody>
+      </p:sp>
+      <p:sp>
+        <p:nvSpPr>
+          <p:cNvPr id="25" name="04 · LOGISTICS     ~1,700     own wag"/>
+          <p:cNvSpPr/>
+          <p:nvPr/>
+        </p:nvSpPr>
+        <p:spPr>
+          <a:xfrm>
+            <a:off x="7524750" y="1295400"/>
+            <a:ext cx="1905000" cy="660400"/>
+          </a:xfrm>
+          <a:prstGeom prst="roundRect">
+            <a:avLst>
+              <a:gd name="adj" fmla="val 6000"/>
+            </a:avLst>
+          </a:prstGeom>
+          <a:solidFill>
+            <a:srgbClr val="183349"/>
+          </a:solidFill>
+          <a:ln>
+            <a:noFill/>
+          </a:ln>
+          <a:effectLst/>
+        </p:spPr>
+        <p:style>
+          <a:lnRef idx="1">
+            <a:schemeClr val="accent1"/>
+          </a:lnRef>
+          <a:fillRef idx="3">
+            <a:schemeClr val="accent1"/>
+          </a:fillRef>
+          <a:effectRef idx="2">
+            <a:schemeClr val="accent1"/>
+          </a:effectRef>
+          <a:fontRef idx="minor">
+            <a:schemeClr val="lt1"/>
+          </a:fontRef>
+        </p:style>
+        <p:txBody>
+          <a:bodyPr rtlCol="0" anchor="ctr" wrap="square" lIns="101600" rIns="101600" tIns="12700" bIns="12700"/>
+          <a:lstStyle/>
+          <a:p>
+            <a:pPr algn="l">
+              <a:lnSpc>
+                <a:spcPct val="100000"/>
+              </a:lnSpc>
+            </a:pPr>
+            <a:r>
+              <a:rPr sz="600" b="1" spc="100">
+                <a:solidFill>
+                  <a:srgbClr val="9FC3E6"/>
+                </a:solidFill>
+                <a:latin typeface="Arial"/>
+              </a:rPr>
+              <a:t>04 · LOGISTICS</a:t>
+            </a:r>
+          </a:p>
+          <a:p>
+            <a:pPr algn="l">
+              <a:lnSpc>
+                <a:spcPct val="100000"/>
+              </a:lnSpc>
+            </a:pPr>
+            <a:r>
+              <a:rPr sz="1800" b="1">
+                <a:solidFill>
+                  <a:srgbClr val="FFFFFF"/>
+                </a:solidFill>
+                <a:latin typeface="Arial"/>
+              </a:rPr>
+              <a:t>~1,700</a:t>
+            </a:r>
+          </a:p>
+          <a:p>
+            <a:pPr algn="l">
+              <a:lnSpc>
+                <a:spcPct val="100000"/>
+              </a:lnSpc>
+            </a:pPr>
+            <a:r>
+              <a:rPr sz="700" b="1">
+                <a:solidFill>
+                  <a:srgbClr val="BFE6D4"/>
+                </a:solidFill>
+                <a:latin typeface="Arial"/>
+              </a:rPr>
+              <a:t>own wagons &amp; tankers</a:t>
+            </a:r>
+          </a:p>
+        </p:txBody>
+      </p:sp>
+      <p:sp>
+        <p:nvSpPr>
+          <p:cNvPr id="26" name="GA Koltar   own rail operator · 3+ Mt/"/>
+          <p:cNvSpPr/>
+          <p:nvPr/>
+        </p:nvSpPr>
+        <p:spPr>
+          <a:xfrm>
+            <a:off x="7524750" y="2070100"/>
+            <a:ext cx="1905000" cy="355600"/>
+          </a:xfrm>
+          <a:prstGeom prst="roundRect">
+            <a:avLst>
+              <a:gd name="adj" fmla="val 10000"/>
+            </a:avLst>
+          </a:prstGeom>
+          <a:solidFill>
+            <a:srgbClr val="FFFFFF"/>
+          </a:solidFill>
+          <a:ln w="9525">
+            <a:solidFill>
+              <a:srgbClr val="C9D2DA"/>
+            </a:solidFill>
+          </a:ln>
+          <a:effectLst/>
+        </p:spPr>
+        <p:style>
+          <a:lnRef idx="1">
+            <a:schemeClr val="accent1"/>
+          </a:lnRef>
+          <a:fillRef idx="3">
+            <a:schemeClr val="accent1"/>
+          </a:fillRef>
+          <a:effectRef idx="2">
+            <a:schemeClr val="accent1"/>
+          </a:effectRef>
+          <a:fontRef idx="minor">
+            <a:schemeClr val="lt1"/>
+          </a:fontRef>
+        </p:style>
+        <p:txBody>
+          <a:bodyPr rtlCol="0" anchor="ctr" wrap="square" lIns="88900" rIns="88900" tIns="12700" bIns="12700"/>
+          <a:lstStyle/>
+          <a:p>
+            <a:pPr algn="l">
+              <a:lnSpc>
+                <a:spcPct val="100000"/>
+              </a:lnSpc>
+            </a:pPr>
+            <a:r>
+              <a:rPr sz="750" b="1">
+                <a:solidFill>
+                  <a:srgbClr val="183349"/>
+                </a:solidFill>
+                <a:latin typeface="Arial"/>
+              </a:rPr>
+              <a:t>GA Koltar</a:t>
+            </a:r>
+          </a:p>
+          <a:p>
+            <a:pPr algn="l">
+              <a:lnSpc>
+                <a:spcPct val="100000"/>
+              </a:lnSpc>
+            </a:pPr>
+            <a:r>
+              <a:rPr sz="650" b="0">
+                <a:solidFill>
+                  <a:srgbClr val="5B6B76"/>
+                </a:solidFill>
+                <a:latin typeface="Arial"/>
+              </a:rPr>
+              <a:t>own rail operator · 3+ Mt/yr</a:t>
+            </a:r>
+          </a:p>
+        </p:txBody>
+      </p:sp>
+      <p:sp>
+        <p:nvSpPr>
+          <p:cNvPr id="27" name="175+ km   of own rail sidings"/>
+          <p:cNvSpPr/>
+          <p:nvPr/>
+        </p:nvSpPr>
+        <p:spPr>
+          <a:xfrm>
+            <a:off x="7524750" y="2476500"/>
+            <a:ext cx="1905000" cy="355600"/>
+          </a:xfrm>
+          <a:prstGeom prst="roundRect">
+            <a:avLst>
+              <a:gd name="adj" fmla="val 10000"/>
+            </a:avLst>
+          </a:prstGeom>
+          <a:solidFill>
+            <a:srgbClr val="FFFFFF"/>
+          </a:solidFill>
+          <a:ln w="9525">
+            <a:solidFill>
+              <a:srgbClr val="C9D2DA"/>
+            </a:solidFill>
+          </a:ln>
+          <a:effectLst/>
+        </p:spPr>
+        <p:style>
+          <a:lnRef idx="1">
+            <a:schemeClr val="accent1"/>
+          </a:lnRef>
+          <a:fillRef idx="3">
+            <a:schemeClr val="accent1"/>
+          </a:fillRef>
+          <a:effectRef idx="2">
+            <a:schemeClr val="accent1"/>
+          </a:effectRef>
+          <a:fontRef idx="minor">
+            <a:schemeClr val="lt1"/>
+          </a:fontRef>
+        </p:style>
+        <p:txBody>
+          <a:bodyPr rtlCol="0" anchor="ctr" wrap="square" lIns="88900" rIns="88900" tIns="12700" bIns="12700"/>
+          <a:lstStyle/>
+          <a:p>
+            <a:pPr algn="l">
+              <a:lnSpc>
+                <a:spcPct val="100000"/>
+              </a:lnSpc>
+            </a:pPr>
+            <a:r>
+              <a:rPr sz="750" b="1">
+                <a:solidFill>
+                  <a:srgbClr val="183349"/>
+                </a:solidFill>
+                <a:latin typeface="Arial"/>
+              </a:rPr>
+              <a:t>175+ km</a:t>
+            </a:r>
+          </a:p>
+          <a:p>
+            <a:pPr algn="l">
+              <a:lnSpc>
+                <a:spcPct val="100000"/>
+              </a:lnSpc>
+            </a:pPr>
+            <a:r>
+              <a:rPr sz="650" b="0">
+                <a:solidFill>
+                  <a:srgbClr val="5B6B76"/>
+                </a:solidFill>
+                <a:latin typeface="Arial"/>
+              </a:rPr>
+              <a:t>of own rail sidings</a:t>
+            </a:r>
+          </a:p>
+        </p:txBody>
+      </p:sp>
+      <p:sp>
+        <p:nvSpPr>
+          <p:cNvPr id="28" name="3 sea terminals   Gdynia · Gdańsk · Po"/>
+          <p:cNvSpPr/>
+          <p:nvPr/>
+        </p:nvSpPr>
+        <p:spPr>
+          <a:xfrm>
+            <a:off x="7524750" y="2882900"/>
+            <a:ext cx="1905000" cy="355600"/>
+          </a:xfrm>
+          <a:prstGeom prst="roundRect">
+            <a:avLst>
+              <a:gd name="adj" fmla="val 10000"/>
+            </a:avLst>
+          </a:prstGeom>
+          <a:solidFill>
+            <a:srgbClr val="FFFFFF"/>
+          </a:solidFill>
+          <a:ln w="9525">
+            <a:solidFill>
+              <a:srgbClr val="C9D2DA"/>
+            </a:solidFill>
+          </a:ln>
+          <a:effectLst/>
+        </p:spPr>
+        <p:style>
+          <a:lnRef idx="1">
+            <a:schemeClr val="accent1"/>
+          </a:lnRef>
+          <a:fillRef idx="3">
+            <a:schemeClr val="accent1"/>
+          </a:fillRef>
+          <a:effectRef idx="2">
+            <a:schemeClr val="accent1"/>
+          </a:effectRef>
+          <a:fontRef idx="minor">
+            <a:schemeClr val="lt1"/>
+          </a:fontRef>
+        </p:style>
+        <p:txBody>
+          <a:bodyPr rtlCol="0" anchor="ctr" wrap="square" lIns="88900" rIns="88900" tIns="12700" bIns="12700"/>
+          <a:lstStyle/>
+          <a:p>
+            <a:pPr algn="l">
+              <a:lnSpc>
+                <a:spcPct val="100000"/>
+              </a:lnSpc>
+            </a:pPr>
+            <a:r>
+              <a:rPr sz="750" b="1">
+                <a:solidFill>
+                  <a:srgbClr val="183349"/>
+                </a:solidFill>
+                <a:latin typeface="Arial"/>
+              </a:rPr>
+              <a:t>3 sea terminals</a:t>
+            </a:r>
+          </a:p>
+          <a:p>
+            <a:pPr algn="l">
+              <a:lnSpc>
+                <a:spcPct val="100000"/>
+              </a:lnSpc>
+            </a:pPr>
+            <a:r>
+              <a:rPr sz="650" b="0">
+                <a:solidFill>
+                  <a:srgbClr val="5B6B76"/>
+                </a:solidFill>
+                <a:latin typeface="Arial"/>
+              </a:rPr>
+              <a:t>Gdynia · Gdańsk · Police</a:t>
+            </a:r>
+          </a:p>
+        </p:txBody>
+      </p:sp>
+      <p:sp>
+        <p:nvSpPr>
+          <p:cNvPr id="29" name="05 · MARKET     ~50%     of Polish fe"/>
+          <p:cNvSpPr/>
+          <p:nvPr/>
+        </p:nvSpPr>
+        <p:spPr>
+          <a:xfrm>
+            <a:off x="9906000" y="1295400"/>
+            <a:ext cx="1905000" cy="660400"/>
+          </a:xfrm>
+          <a:prstGeom prst="roundRect">
+            <a:avLst>
+              <a:gd name="adj" fmla="val 6000"/>
+            </a:avLst>
+          </a:prstGeom>
+          <a:solidFill>
+            <a:srgbClr val="183349"/>
+          </a:solidFill>
+          <a:ln>
+            <a:noFill/>
+          </a:ln>
+          <a:effectLst/>
+        </p:spPr>
+        <p:style>
+          <a:lnRef idx="1">
+            <a:schemeClr val="accent1"/>
+          </a:lnRef>
+          <a:fillRef idx="3">
+            <a:schemeClr val="accent1"/>
+          </a:fillRef>
+          <a:effectRef idx="2">
+            <a:schemeClr val="accent1"/>
+          </a:effectRef>
+          <a:fontRef idx="minor">
+            <a:schemeClr val="lt1"/>
+          </a:fontRef>
+        </p:style>
+        <p:txBody>
+          <a:bodyPr rtlCol="0" anchor="ctr" wrap="square" lIns="101600" rIns="101600" tIns="12700" bIns="12700"/>
+          <a:lstStyle/>
+          <a:p>
+            <a:pPr algn="l">
+              <a:lnSpc>
+                <a:spcPct val="100000"/>
+              </a:lnSpc>
+            </a:pPr>
+            <a:r>
+              <a:rPr sz="600" b="1" spc="100">
+                <a:solidFill>
+                  <a:srgbClr val="9FC3E6"/>
+                </a:solidFill>
+                <a:latin typeface="Arial"/>
+              </a:rPr>
+              <a:t>05 · MARKET</a:t>
+            </a:r>
+          </a:p>
+          <a:p>
+            <a:pPr algn="l">
+              <a:lnSpc>
+                <a:spcPct val="100000"/>
+              </a:lnSpc>
+            </a:pPr>
+            <a:r>
+              <a:rPr sz="1800" b="1">
+                <a:solidFill>
+                  <a:srgbClr val="FFFFFF"/>
+                </a:solidFill>
+                <a:latin typeface="Arial"/>
+              </a:rPr>
+              <a:t>~50%</a:t>
+            </a:r>
+          </a:p>
+          <a:p>
+            <a:pPr algn="l">
+              <a:lnSpc>
+                <a:spcPct val="100000"/>
+              </a:lnSpc>
+            </a:pPr>
+            <a:r>
+              <a:rPr sz="700" b="1">
+                <a:solidFill>
+                  <a:srgbClr val="BFE6D4"/>
+                </a:solidFill>
+                <a:latin typeface="Arial"/>
+              </a:rPr>
+              <a:t>of Polish fertilizers</a:t>
+            </a:r>
+          </a:p>
+        </p:txBody>
+      </p:sp>
+      <p:sp>
+        <p:nvSpPr>
+          <p:cNvPr id="30" name="68 distributors   authorised, nationwi"/>
+          <p:cNvSpPr/>
+          <p:nvPr/>
+        </p:nvSpPr>
+        <p:spPr>
+          <a:xfrm>
+            <a:off x="9906000" y="2070100"/>
+            <a:ext cx="1905000" cy="355600"/>
+          </a:xfrm>
+          <a:prstGeom prst="roundRect">
+            <a:avLst>
+              <a:gd name="adj" fmla="val 10000"/>
+            </a:avLst>
+          </a:prstGeom>
+          <a:solidFill>
+            <a:srgbClr val="FFFFFF"/>
+          </a:solidFill>
+          <a:ln w="9525">
+            <a:solidFill>
+              <a:srgbClr val="C9D2DA"/>
+            </a:solidFill>
+          </a:ln>
+          <a:effectLst/>
+        </p:spPr>
+        <p:style>
+          <a:lnRef idx="1">
+            <a:schemeClr val="accent1"/>
+          </a:lnRef>
+          <a:fillRef idx="3">
+            <a:schemeClr val="accent1"/>
+          </a:fillRef>
+          <a:effectRef idx="2">
+            <a:schemeClr val="accent1"/>
+          </a:effectRef>
+          <a:fontRef idx="minor">
+            <a:schemeClr val="lt1"/>
+          </a:fontRef>
+        </p:style>
+        <p:txBody>
+          <a:bodyPr rtlCol="0" anchor="ctr" wrap="square" lIns="88900" rIns="88900" tIns="12700" bIns="12700"/>
+          <a:lstStyle/>
+          <a:p>
+            <a:pPr algn="l">
+              <a:lnSpc>
+                <a:spcPct val="100000"/>
+              </a:lnSpc>
+            </a:pPr>
+            <a:r>
+              <a:rPr sz="750" b="1">
+                <a:solidFill>
+                  <a:srgbClr val="183349"/>
+                </a:solidFill>
+                <a:latin typeface="Arial"/>
+              </a:rPr>
+              <a:t>68 distributors</a:t>
+            </a:r>
+          </a:p>
+          <a:p>
+            <a:pPr algn="l">
+              <a:lnSpc>
+                <a:spcPct val="100000"/>
+              </a:lnSpc>
+            </a:pPr>
+            <a:r>
+              <a:rPr sz="650" b="0">
+                <a:solidFill>
+                  <a:srgbClr val="5B6B76"/>
+                </a:solidFill>
+                <a:latin typeface="Arial"/>
+              </a:rPr>
+              <a:t>authorised, nationwide</a:t>
+            </a:r>
+          </a:p>
+        </p:txBody>
+      </p:sp>
+      <p:sp>
+        <p:nvSpPr>
+          <p:cNvPr id="31" name="Market share   AN/CAN 45% · NPK 42%"/>
+          <p:cNvSpPr/>
+          <p:nvPr/>
+        </p:nvSpPr>
+        <p:spPr>
+          <a:xfrm>
+            <a:off x="9906000" y="2476500"/>
+            <a:ext cx="1905000" cy="355600"/>
+          </a:xfrm>
+          <a:prstGeom prst="roundRect">
+            <a:avLst>
+              <a:gd name="adj" fmla="val 10000"/>
+            </a:avLst>
+          </a:prstGeom>
+          <a:solidFill>
+            <a:srgbClr val="FFFFFF"/>
+          </a:solidFill>
+          <a:ln w="9525">
+            <a:solidFill>
+              <a:srgbClr val="C9D2DA"/>
+            </a:solidFill>
+          </a:ln>
+          <a:effectLst/>
+        </p:spPr>
+        <p:style>
+          <a:lnRef idx="1">
+            <a:schemeClr val="accent1"/>
+          </a:lnRef>
+          <a:fillRef idx="3">
+            <a:schemeClr val="accent1"/>
+          </a:fillRef>
+          <a:effectRef idx="2">
+            <a:schemeClr val="accent1"/>
+          </a:effectRef>
+          <a:fontRef idx="minor">
+            <a:schemeClr val="lt1"/>
+          </a:fontRef>
+        </p:style>
+        <p:txBody>
+          <a:bodyPr rtlCol="0" anchor="ctr" wrap="square" lIns="88900" rIns="88900" tIns="12700" bIns="12700"/>
+          <a:lstStyle/>
+          <a:p>
+            <a:pPr algn="l">
+              <a:lnSpc>
+                <a:spcPct val="100000"/>
+              </a:lnSpc>
+            </a:pPr>
+            <a:r>
+              <a:rPr sz="750" b="1">
+                <a:solidFill>
+                  <a:srgbClr val="183349"/>
+                </a:solidFill>
+                <a:latin typeface="Arial"/>
+              </a:rPr>
+              <a:t>Market share</a:t>
+            </a:r>
+          </a:p>
+          <a:p>
+            <a:pPr algn="l">
+              <a:lnSpc>
+                <a:spcPct val="100000"/>
+              </a:lnSpc>
+            </a:pPr>
+            <a:r>
+              <a:rPr sz="650" b="0">
+                <a:solidFill>
+                  <a:srgbClr val="5B6B76"/>
+                </a:solidFill>
+                <a:latin typeface="Arial"/>
+              </a:rPr>
+              <a:t>AN/CAN 45% · NPK 42%</a:t>
+            </a:r>
+          </a:p>
+        </p:txBody>
+      </p:sp>
+      <p:sp>
+        <p:nvSpPr>
+          <p:cNvPr id="32" name="FARMERS   end customer · invisible tod"/>
+          <p:cNvSpPr/>
+          <p:nvPr/>
+        </p:nvSpPr>
+        <p:spPr>
+          <a:xfrm>
+            <a:off x="9906000" y="2882900"/>
+            <a:ext cx="1905000" cy="355600"/>
+          </a:xfrm>
+          <a:prstGeom prst="roundRect">
+            <a:avLst>
+              <a:gd name="adj" fmla="val 10000"/>
+            </a:avLst>
+          </a:prstGeom>
+          <a:solidFill>
+            <a:srgbClr val="FFFFFF"/>
+          </a:solidFill>
+          <a:ln w="19050">
+            <a:solidFill>
+              <a:srgbClr val="B23A3A"/>
+            </a:solidFill>
+            <a:prstDash val="dash"/>
+          </a:ln>
+          <a:effectLst/>
+        </p:spPr>
+        <p:style>
+          <a:lnRef idx="1">
+            <a:schemeClr val="accent1"/>
+          </a:lnRef>
+          <a:fillRef idx="3">
+            <a:schemeClr val="accent1"/>
+          </a:fillRef>
+          <a:effectRef idx="2">
+            <a:schemeClr val="accent1"/>
+          </a:effectRef>
+          <a:fontRef idx="minor">
+            <a:schemeClr val="lt1"/>
+          </a:fontRef>
+        </p:style>
+        <p:txBody>
+          <a:bodyPr rtlCol="0" anchor="ctr" wrap="square" lIns="88900" rIns="88900" tIns="12700" bIns="12700"/>
+          <a:lstStyle/>
+          <a:p>
+            <a:pPr algn="l">
+              <a:lnSpc>
+                <a:spcPct val="100000"/>
+              </a:lnSpc>
+            </a:pPr>
+            <a:r>
+              <a:rPr sz="750" b="1">
+                <a:solidFill>
+                  <a:srgbClr val="B23A3A"/>
+                </a:solidFill>
+                <a:latin typeface="Arial"/>
+              </a:rPr>
+              <a:t>FARMERS</a:t>
+            </a:r>
+          </a:p>
+          <a:p>
+            <a:pPr algn="l">
+              <a:lnSpc>
+                <a:spcPct val="100000"/>
+              </a:lnSpc>
+            </a:pPr>
+            <a:r>
+              <a:rPr sz="650" b="0">
+                <a:solidFill>
+                  <a:srgbClr val="B23A3A"/>
+                </a:solidFill>
+                <a:latin typeface="Arial"/>
+              </a:rPr>
+              <a:t>end customer · invisible today</a:t>
+            </a:r>
+          </a:p>
+        </p:txBody>
+      </p:sp>
+      <p:sp>
+        <p:nvSpPr>
+          <p:cNvPr id="33" name="Shape"/>
+          <p:cNvSpPr/>
+          <p:nvPr/>
+        </p:nvSpPr>
+        <p:spPr>
+          <a:xfrm>
+            <a:off x="254000" y="4521200"/>
+            <a:ext cx="11684000" cy="1244600"/>
+          </a:xfrm>
+          <a:prstGeom prst="roundRect">
+            <a:avLst>
+              <a:gd name="adj" fmla="val 4000"/>
+            </a:avLst>
+          </a:prstGeom>
+          <a:solidFill>
+            <a:srgbClr val="E6F2EC"/>
+          </a:solidFill>
+          <a:ln w="19050">
+            <a:solidFill>
+              <a:srgbClr val="1F7A5A"/>
+            </a:solidFill>
+          </a:ln>
+          <a:effectLst/>
+        </p:spPr>
+        <p:style>
+          <a:lnRef idx="1">
+            <a:schemeClr val="accent1"/>
+          </a:lnRef>
+          <a:fillRef idx="3">
+            <a:schemeClr val="accent1"/>
+          </a:fillRef>
+          <a:effectRef idx="2">
+            <a:schemeClr val="accent1"/>
+          </a:effectRef>
+          <a:fontRef idx="minor">
+            <a:schemeClr val="lt1"/>
+          </a:fontRef>
+        </p:style>
+        <p:txBody>
+          <a:bodyPr rtlCol="0" anchor="ctr"/>
+          <a:lstStyle/>
+          <a:p>
+            <a:pPr algn="ctr"/>
+          </a:p>
+        </p:txBody>
+      </p:sp>
+      <p:sp>
+        <p:nvSpPr>
+          <p:cNvPr id="34" name="GAia &amp;nbsp;&amp;nbsp; DIGITAL DEMAND LAYER"/>
+          <p:cNvSpPr/>
+          <p:nvPr/>
+        </p:nvSpPr>
+        <p:spPr>
+          <a:xfrm>
+            <a:off x="2413000" y="4584700"/>
+            <a:ext cx="7620000" cy="177800"/>
+          </a:xfrm>
+          <a:prstGeom prst="rect">
+            <a:avLst/>
+          </a:prstGeom>
+          <a:noFill/>
+          <a:ln>
+            <a:noFill/>
+          </a:ln>
+          <a:effectLst/>
+        </p:spPr>
+        <p:style>
+          <a:lnRef idx="1">
+            <a:schemeClr val="accent1"/>
+          </a:lnRef>
+          <a:fillRef idx="3">
+            <a:schemeClr val="accent1"/>
+          </a:fillRef>
+          <a:effectRef idx="2">
+            <a:schemeClr val="accent1"/>
+          </a:effectRef>
+          <a:fontRef idx="minor">
+            <a:schemeClr val="lt1"/>
+          </a:fontRef>
+        </p:style>
+        <p:txBody>
+          <a:bodyPr rtlCol="0" anchor="ctr" wrap="square" lIns="0" rIns="0" tIns="12700" bIns="12700"/>
+          <a:lstStyle/>
+          <a:p>
+            <a:pPr algn="ctr">
+              <a:lnSpc>
+                <a:spcPct val="100000"/>
+              </a:lnSpc>
+            </a:pPr>
+            <a:r>
+              <a:rPr sz="1100" b="1">
+                <a:solidFill>
+                  <a:srgbClr val="1F7A5A"/>
+                </a:solidFill>
+                <a:latin typeface="Arial"/>
+              </a:rPr>
+              <a:t>GAia</a:t>
+            </a:r>
+            <a:r>
+              <a:rPr sz="700" b="0">
+                <a:solidFill>
+                  <a:srgbClr val="183349"/>
+                </a:solidFill>
+                <a:latin typeface="Arial"/>
+              </a:rPr>
+              <a:t>  </a:t>
+            </a:r>
+            <a:r>
+              <a:rPr sz="700" b="1" spc="100">
+                <a:solidFill>
+                  <a:srgbClr val="183349"/>
+                </a:solidFill>
+                <a:latin typeface="Arial"/>
+              </a:rPr>
+              <a:t>DIGITAL DEMAND LAYER</a:t>
+            </a:r>
+            <a:r>
+              <a:rPr sz="700" b="0">
+                <a:solidFill>
+                  <a:srgbClr val="183349"/>
+                </a:solidFill>
+                <a:latin typeface="Arial"/>
+              </a:rPr>
+              <a:t>  </a:t>
+            </a:r>
+            <a:r>
+              <a:rPr sz="700" b="1">
+                <a:solidFill>
+                  <a:srgbClr val="B23A3A"/>
+                </a:solidFill>
+                <a:latin typeface="Arial"/>
+              </a:rPr>
+              <a:t>· THE ONLY MISSING LINK · TO BE BUILT</a:t>
+            </a:r>
+          </a:p>
+        </p:txBody>
+      </p:sp>
+      <p:sp>
+        <p:nvSpPr>
+          <p:cNvPr id="35" name="ONE GROUP PLAN   13 weeks: which plant,"/>
+          <p:cNvSpPr/>
+          <p:nvPr/>
+        </p:nvSpPr>
+        <p:spPr>
+          <a:xfrm>
+            <a:off x="381000" y="4851400"/>
+            <a:ext cx="1587500" cy="736600"/>
+          </a:xfrm>
+          <a:prstGeom prst="roundRect">
+            <a:avLst>
+              <a:gd name="adj" fmla="val 10000"/>
+            </a:avLst>
+          </a:prstGeom>
+          <a:solidFill>
+            <a:srgbClr val="1F7A5A"/>
+          </a:solidFill>
+          <a:ln>
+            <a:noFill/>
+          </a:ln>
+          <a:effectLst/>
+        </p:spPr>
+        <p:style>
+          <a:lnRef idx="1">
+            <a:schemeClr val="accent1"/>
+          </a:lnRef>
+          <a:fillRef idx="3">
+            <a:schemeClr val="accent1"/>
+          </a:fillRef>
+          <a:effectRef idx="2">
+            <a:schemeClr val="accent1"/>
+          </a:effectRef>
+          <a:fontRef idx="minor">
+            <a:schemeClr val="lt1"/>
+          </a:fontRef>
+        </p:style>
+        <p:txBody>
+          <a:bodyPr rtlCol="0" anchor="ctr" wrap="square" lIns="25400" rIns="25400" tIns="12700" bIns="12700"/>
+          <a:lstStyle/>
+          <a:p>
+            <a:pPr algn="ctr">
+              <a:lnSpc>
+                <a:spcPct val="100000"/>
+              </a:lnSpc>
+            </a:pPr>
+            <a:r>
+              <a:rPr sz="950" b="1">
+                <a:solidFill>
+                  <a:srgbClr val="FFFFFF"/>
+                </a:solidFill>
+                <a:latin typeface="Arial"/>
+              </a:rPr>
+              <a:t>ONE GROUP PLAN</a:t>
+            </a:r>
+          </a:p>
+          <a:p>
+            <a:pPr algn="ctr">
+              <a:lnSpc>
+                <a:spcPct val="100000"/>
+              </a:lnSpc>
+            </a:pPr>
+            <a:r>
+              <a:rPr sz="650" b="0">
+                <a:solidFill>
+                  <a:srgbClr val="E6F2EC"/>
+                </a:solidFill>
+                <a:latin typeface="Arial"/>
+              </a:rPr>
+              <a:t>13 weeks: which plant, warehouse, wagon</a:t>
+            </a:r>
+          </a:p>
+        </p:txBody>
+      </p:sp>
+      <p:sp>
+        <p:nvSpPr>
+          <p:cNvPr id="36" name="Demand signal   real sell-out, not dist"/>
+          <p:cNvSpPr/>
+          <p:nvPr/>
+        </p:nvSpPr>
+        <p:spPr>
+          <a:xfrm>
+            <a:off x="2349500" y="4851400"/>
+            <a:ext cx="1587500" cy="736600"/>
+          </a:xfrm>
+          <a:prstGeom prst="roundRect">
+            <a:avLst>
+              <a:gd name="adj" fmla="val 10000"/>
+            </a:avLst>
+          </a:prstGeom>
+          <a:solidFill>
+            <a:srgbClr val="FFFFFF"/>
+          </a:solidFill>
+          <a:ln w="14287">
+            <a:solidFill>
+              <a:srgbClr val="1F7A5A"/>
+            </a:solidFill>
+          </a:ln>
+          <a:effectLst/>
+        </p:spPr>
+        <p:style>
+          <a:lnRef idx="1">
+            <a:schemeClr val="accent1"/>
+          </a:lnRef>
+          <a:fillRef idx="3">
+            <a:schemeClr val="accent1"/>
+          </a:fillRef>
+          <a:effectRef idx="2">
+            <a:schemeClr val="accent1"/>
+          </a:effectRef>
+          <a:fontRef idx="minor">
+            <a:schemeClr val="lt1"/>
+          </a:fontRef>
+        </p:style>
+        <p:txBody>
+          <a:bodyPr rtlCol="0" anchor="ctr" wrap="square" lIns="25400" rIns="25400" tIns="12700" bIns="12700"/>
+          <a:lstStyle/>
+          <a:p>
+            <a:pPr algn="ctr">
+              <a:lnSpc>
+                <a:spcPct val="100000"/>
+              </a:lnSpc>
+            </a:pPr>
+            <a:r>
+              <a:rPr sz="850" b="1">
+                <a:solidFill>
+                  <a:srgbClr val="183349"/>
+                </a:solidFill>
+                <a:latin typeface="Arial"/>
+              </a:rPr>
+              <a:t>Demand signal</a:t>
+            </a:r>
+          </a:p>
+          <a:p>
+            <a:pPr algn="ctr">
+              <a:lnSpc>
+                <a:spcPct val="100000"/>
+              </a:lnSpc>
+            </a:pPr>
+            <a:r>
+              <a:rPr sz="650" b="0">
+                <a:solidFill>
+                  <a:srgbClr val="5B6B76"/>
+                </a:solidFill>
+                <a:latin typeface="Arial"/>
+              </a:rPr>
+              <a:t>real sell-out, not distributor stock</a:t>
+            </a:r>
+          </a:p>
+        </p:txBody>
+      </p:sp>
+      <p:sp>
+        <p:nvSpPr>
+          <p:cNvPr id="37" name="Order via distributor   fulfilled by th"/>
+          <p:cNvSpPr/>
+          <p:nvPr/>
+        </p:nvSpPr>
+        <p:spPr>
+          <a:xfrm>
+            <a:off x="4318000" y="4851400"/>
+            <a:ext cx="1587500" cy="736600"/>
+          </a:xfrm>
+          <a:prstGeom prst="roundRect">
+            <a:avLst>
+              <a:gd name="adj" fmla="val 10000"/>
+            </a:avLst>
+          </a:prstGeom>
+          <a:solidFill>
+            <a:srgbClr val="FFFFFF"/>
+          </a:solidFill>
+          <a:ln w="14287">
+            <a:solidFill>
+              <a:srgbClr val="1F7A5A"/>
+            </a:solidFill>
+          </a:ln>
+          <a:effectLst/>
+        </p:spPr>
+        <p:style>
+          <a:lnRef idx="1">
+            <a:schemeClr val="accent1"/>
+          </a:lnRef>
+          <a:fillRef idx="3">
+            <a:schemeClr val="accent1"/>
+          </a:fillRef>
+          <a:effectRef idx="2">
+            <a:schemeClr val="accent1"/>
+          </a:effectRef>
+          <a:fontRef idx="minor">
+            <a:schemeClr val="lt1"/>
+          </a:fontRef>
+        </p:style>
+        <p:txBody>
+          <a:bodyPr rtlCol="0" anchor="ctr" wrap="square" lIns="25400" rIns="25400" tIns="12700" bIns="12700"/>
+          <a:lstStyle/>
+          <a:p>
+            <a:pPr algn="ctr">
+              <a:lnSpc>
+                <a:spcPct val="100000"/>
+              </a:lnSpc>
+            </a:pPr>
+            <a:r>
+              <a:rPr sz="850" b="1">
+                <a:solidFill>
+                  <a:srgbClr val="183349"/>
+                </a:solidFill>
+                <a:latin typeface="Arial"/>
+              </a:rPr>
+              <a:t>Order via distributor</a:t>
+            </a:r>
+          </a:p>
+          <a:p>
+            <a:pPr algn="ctr">
+              <a:lnSpc>
+                <a:spcPct val="100000"/>
+              </a:lnSpc>
+            </a:pPr>
+            <a:r>
+              <a:rPr sz="650" b="0">
+                <a:solidFill>
+                  <a:srgbClr val="5B6B76"/>
+                </a:solidFill>
+                <a:latin typeface="Arial"/>
+              </a:rPr>
+              <a:t>fulfilled by the 68 partners</a:t>
+            </a:r>
+          </a:p>
+        </p:txBody>
+      </p:sp>
+      <p:sp>
+        <p:nvSpPr>
+          <p:cNvPr id="38" name="Basket   product · volume · timing"/>
+          <p:cNvSpPr/>
+          <p:nvPr/>
+        </p:nvSpPr>
+        <p:spPr>
+          <a:xfrm>
+            <a:off x="6286500" y="4851400"/>
+            <a:ext cx="1587500" cy="736600"/>
+          </a:xfrm>
+          <a:prstGeom prst="roundRect">
+            <a:avLst>
+              <a:gd name="adj" fmla="val 10000"/>
+            </a:avLst>
+          </a:prstGeom>
+          <a:solidFill>
+            <a:srgbClr val="FFFFFF"/>
+          </a:solidFill>
+          <a:ln w="14287">
+            <a:solidFill>
+              <a:srgbClr val="1F7A5A"/>
+            </a:solidFill>
+          </a:ln>
+          <a:effectLst/>
+        </p:spPr>
+        <p:style>
+          <a:lnRef idx="1">
+            <a:schemeClr val="accent1"/>
+          </a:lnRef>
+          <a:fillRef idx="3">
+            <a:schemeClr val="accent1"/>
+          </a:fillRef>
+          <a:effectRef idx="2">
+            <a:schemeClr val="accent1"/>
+          </a:effectRef>
+          <a:fontRef idx="minor">
+            <a:schemeClr val="lt1"/>
+          </a:fontRef>
+        </p:style>
+        <p:txBody>
+          <a:bodyPr rtlCol="0" anchor="ctr" wrap="square" lIns="25400" rIns="25400" tIns="12700" bIns="12700"/>
+          <a:lstStyle/>
+          <a:p>
+            <a:pPr algn="ctr">
+              <a:lnSpc>
+                <a:spcPct val="100000"/>
+              </a:lnSpc>
+            </a:pPr>
+            <a:r>
+              <a:rPr sz="850" b="1">
+                <a:solidFill>
+                  <a:srgbClr val="183349"/>
+                </a:solidFill>
+                <a:latin typeface="Arial"/>
+              </a:rPr>
+              <a:t>Basket</a:t>
+            </a:r>
+          </a:p>
+          <a:p>
+            <a:pPr algn="ctr">
+              <a:lnSpc>
+                <a:spcPct val="100000"/>
+              </a:lnSpc>
+            </a:pPr>
+            <a:r>
+              <a:rPr sz="650" b="0">
+                <a:solidFill>
+                  <a:srgbClr val="5B6B76"/>
+                </a:solidFill>
+                <a:latin typeface="Arial"/>
+              </a:rPr>
+              <a:t>product · volume · timing</a:t>
+            </a:r>
+          </a:p>
+        </p:txBody>
+      </p:sp>
+      <p:sp>
+        <p:nvSpPr>
+          <p:cNvPr id="39" name="Fertilisation plan   per field, crop an"/>
+          <p:cNvSpPr/>
+          <p:nvPr/>
+        </p:nvSpPr>
+        <p:spPr>
+          <a:xfrm>
+            <a:off x="8255000" y="4851400"/>
+            <a:ext cx="1587500" cy="736600"/>
+          </a:xfrm>
+          <a:prstGeom prst="roundRect">
+            <a:avLst>
+              <a:gd name="adj" fmla="val 10000"/>
+            </a:avLst>
+          </a:prstGeom>
+          <a:solidFill>
+            <a:srgbClr val="FFFFFF"/>
+          </a:solidFill>
+          <a:ln w="14287">
+            <a:solidFill>
+              <a:srgbClr val="1F7A5A"/>
+            </a:solidFill>
+          </a:ln>
+          <a:effectLst/>
+        </p:spPr>
+        <p:style>
+          <a:lnRef idx="1">
+            <a:schemeClr val="accent1"/>
+          </a:lnRef>
+          <a:fillRef idx="3">
+            <a:schemeClr val="accent1"/>
+          </a:fillRef>
+          <a:effectRef idx="2">
+            <a:schemeClr val="accent1"/>
+          </a:effectRef>
+          <a:fontRef idx="minor">
+            <a:schemeClr val="lt1"/>
+          </a:fontRef>
+        </p:style>
+        <p:txBody>
+          <a:bodyPr rtlCol="0" anchor="ctr" wrap="square" lIns="25400" rIns="25400" tIns="12700" bIns="12700"/>
+          <a:lstStyle/>
+          <a:p>
+            <a:pPr algn="ctr">
+              <a:lnSpc>
+                <a:spcPct val="100000"/>
+              </a:lnSpc>
+            </a:pPr>
+            <a:r>
+              <a:rPr sz="850" b="1">
+                <a:solidFill>
+                  <a:srgbClr val="183349"/>
+                </a:solidFill>
+                <a:latin typeface="Arial"/>
+              </a:rPr>
+              <a:t>Fertilisation plan</a:t>
+            </a:r>
+          </a:p>
+          <a:p>
+            <a:pPr algn="ctr">
+              <a:lnSpc>
+                <a:spcPct val="100000"/>
+              </a:lnSpc>
+            </a:pPr>
+            <a:r>
+              <a:rPr sz="650" b="0">
+                <a:solidFill>
+                  <a:srgbClr val="5B6B76"/>
+                </a:solidFill>
+                <a:latin typeface="Arial"/>
+              </a:rPr>
+              <a:t>per field, crop and soil</a:t>
+            </a:r>
+          </a:p>
+        </p:txBody>
+      </p:sp>
+      <p:sp>
+        <p:nvSpPr>
+          <p:cNvPr id="40" name="Farmer   field data in, advice out"/>
+          <p:cNvSpPr/>
+          <p:nvPr/>
+        </p:nvSpPr>
+        <p:spPr>
+          <a:xfrm>
+            <a:off x="10223500" y="4851400"/>
+            <a:ext cx="1587500" cy="736600"/>
+          </a:xfrm>
+          <a:prstGeom prst="roundRect">
+            <a:avLst>
+              <a:gd name="adj" fmla="val 10000"/>
+            </a:avLst>
+          </a:prstGeom>
+          <a:solidFill>
+            <a:srgbClr val="FFFFFF"/>
+          </a:solidFill>
+          <a:ln w="14287">
+            <a:solidFill>
+              <a:srgbClr val="1F7A5A"/>
+            </a:solidFill>
+          </a:ln>
+          <a:effectLst/>
+        </p:spPr>
+        <p:style>
+          <a:lnRef idx="1">
+            <a:schemeClr val="accent1"/>
+          </a:lnRef>
+          <a:fillRef idx="3">
+            <a:schemeClr val="accent1"/>
+          </a:fillRef>
+          <a:effectRef idx="2">
+            <a:schemeClr val="accent1"/>
+          </a:effectRef>
+          <a:fontRef idx="minor">
+            <a:schemeClr val="lt1"/>
+          </a:fontRef>
+        </p:style>
+        <p:txBody>
+          <a:bodyPr rtlCol="0" anchor="ctr" wrap="square" lIns="25400" rIns="25400" tIns="12700" bIns="12700"/>
+          <a:lstStyle/>
+          <a:p>
+            <a:pPr algn="ctr">
+              <a:lnSpc>
+                <a:spcPct val="100000"/>
+              </a:lnSpc>
+            </a:pPr>
+            <a:r>
+              <a:rPr sz="850" b="1">
+                <a:solidFill>
+                  <a:srgbClr val="183349"/>
+                </a:solidFill>
+                <a:latin typeface="Arial"/>
+              </a:rPr>
+              <a:t>Farmer</a:t>
+            </a:r>
+          </a:p>
+          <a:p>
+            <a:pPr algn="ctr">
+              <a:lnSpc>
+                <a:spcPct val="100000"/>
+              </a:lnSpc>
+            </a:pPr>
+            <a:r>
+              <a:rPr sz="650" b="0">
+                <a:solidFill>
+                  <a:srgbClr val="5B6B76"/>
+                </a:solidFill>
+                <a:latin typeface="Arial"/>
+              </a:rPr>
+              <a:t>field data in, advice out</a:t>
+            </a:r>
+          </a:p>
+        </p:txBody>
+      </p:sp>
+      <p:sp>
+        <p:nvSpPr>
+          <p:cNvPr id="41" name="Shape"/>
+          <p:cNvSpPr/>
+          <p:nvPr/>
+        </p:nvSpPr>
+        <p:spPr>
+          <a:xfrm>
+            <a:off x="1333500" y="4343400"/>
+            <a:ext cx="7143750" cy="25400"/>
+          </a:xfrm>
+          <a:prstGeom prst="rect">
+            <a:avLst/>
+          </a:prstGeom>
+          <a:solidFill>
+            <a:srgbClr val="1F7A5A"/>
+          </a:solidFill>
+          <a:ln>
+            <a:noFill/>
+          </a:ln>
+          <a:effectLst/>
+        </p:spPr>
+        <p:style>
+          <a:lnRef idx="1">
+            <a:schemeClr val="accent1"/>
+          </a:lnRef>
+          <a:fillRef idx="3">
+            <a:schemeClr val="accent1"/>
+          </a:fillRef>
+          <a:effectRef idx="2">
+            <a:schemeClr val="accent1"/>
+          </a:effectRef>
+          <a:fontRef idx="minor">
+            <a:schemeClr val="lt1"/>
+          </a:fontRef>
+        </p:style>
+        <p:txBody>
+          <a:bodyPr rtlCol="0" anchor="ctr"/>
+          <a:lstStyle/>
+          <a:p>
+            <a:pPr algn="ctr"/>
+          </a:p>
+        </p:txBody>
+      </p:sp>
+      <p:sp>
+        <p:nvSpPr>
+          <p:cNvPr id="42" name="ONE PLAN DRIVES THE WHOLE CHAIN"/>
+          <p:cNvSpPr/>
+          <p:nvPr/>
+        </p:nvSpPr>
+        <p:spPr>
+          <a:xfrm>
+            <a:off x="3825875" y="4260850"/>
+            <a:ext cx="2159000" cy="190500"/>
+          </a:xfrm>
+          <a:prstGeom prst="roundRect">
+            <a:avLst>
+              <a:gd name="adj" fmla="val 50000"/>
+            </a:avLst>
+          </a:prstGeom>
+          <a:solidFill>
+            <a:srgbClr val="FFFFFF"/>
+          </a:solidFill>
+          <a:ln w="19050">
+            <a:solidFill>
+              <a:srgbClr val="1F7A5A"/>
+            </a:solidFill>
+          </a:ln>
+          <a:effectLst/>
+        </p:spPr>
+        <p:style>
+          <a:lnRef idx="1">
+            <a:schemeClr val="accent1"/>
+          </a:lnRef>
+          <a:fillRef idx="3">
+            <a:schemeClr val="accent1"/>
+          </a:fillRef>
+          <a:effectRef idx="2">
+            <a:schemeClr val="accent1"/>
+          </a:effectRef>
+          <a:fontRef idx="minor">
+            <a:schemeClr val="lt1"/>
+          </a:fontRef>
+        </p:style>
+        <p:txBody>
+          <a:bodyPr rtlCol="0" anchor="ctr" wrap="square" lIns="25400" rIns="25400" tIns="12700" bIns="12700"/>
+          <a:lstStyle/>
+          <a:p>
+            <a:pPr algn="ctr">
+              <a:lnSpc>
+                <a:spcPct val="100000"/>
+              </a:lnSpc>
+            </a:pPr>
+            <a:r>
+              <a:rPr sz="700" b="1">
+                <a:solidFill>
+                  <a:srgbClr val="1F7A5A"/>
+                </a:solidFill>
+                <a:latin typeface="Arial"/>
+              </a:rPr>
+              <a:t>ONE PLAN DRIVES THE WHOLE CHAIN</a:t>
+            </a:r>
+          </a:p>
+        </p:txBody>
+      </p:sp>
+      <p:sp>
+        <p:nvSpPr>
+          <p:cNvPr id="43" name="ONE DATA BACKBONE, ALREADY IN PLACE &amp;nb"/>
+          <p:cNvSpPr/>
+          <p:nvPr/>
+        </p:nvSpPr>
+        <p:spPr>
+          <a:xfrm>
+            <a:off x="254000" y="5867400"/>
+            <a:ext cx="11684000" cy="292100"/>
+          </a:xfrm>
+          <a:prstGeom prst="roundRect">
+            <a:avLst>
+              <a:gd name="adj" fmla="val 12000"/>
+            </a:avLst>
+          </a:prstGeom>
+          <a:solidFill>
+            <a:srgbClr val="183349"/>
+          </a:solidFill>
+          <a:ln>
+            <a:noFill/>
+          </a:ln>
+          <a:effectLst/>
+        </p:spPr>
+        <p:style>
+          <a:lnRef idx="1">
+            <a:schemeClr val="accent1"/>
+          </a:lnRef>
+          <a:fillRef idx="3">
+            <a:schemeClr val="accent1"/>
+          </a:fillRef>
+          <a:effectRef idx="2">
+            <a:schemeClr val="accent1"/>
+          </a:effectRef>
+          <a:fontRef idx="minor">
+            <a:schemeClr val="lt1"/>
+          </a:fontRef>
+        </p:style>
+        <p:txBody>
+          <a:bodyPr rtlCol="0" anchor="ctr" wrap="square" lIns="25400" rIns="25400" tIns="12700" bIns="12700"/>
+          <a:lstStyle/>
+          <a:p>
+            <a:pPr algn="ctr">
+              <a:lnSpc>
+                <a:spcPct val="100000"/>
+              </a:lnSpc>
+            </a:pPr>
+            <a:r>
+              <a:rPr sz="750" b="1" spc="100">
+                <a:solidFill>
+                  <a:srgbClr val="9FC3E6"/>
+                </a:solidFill>
+                <a:latin typeface="Arial"/>
+              </a:rPr>
+              <a:t>ONE DATA BACKBONE, ALREADY IN PLACE</a:t>
+            </a:r>
+            <a:r>
+              <a:rPr sz="750" b="0">
+                <a:solidFill>
+                  <a:srgbClr val="FFFFFF"/>
+                </a:solidFill>
+                <a:latin typeface="Arial"/>
+              </a:rPr>
+              <a:t>   SAP (SD · MM · FI/CO · PP-PI · QM · PM)  ·  CRM  ·  distributor portal  ·  plant automation (OT)   </a:t>
+            </a:r>
+            <a:r>
+              <a:rPr sz="750" b="1">
+                <a:solidFill>
+                  <a:srgbClr val="BFE6D4"/>
+                </a:solidFill>
+                <a:latin typeface="Arial"/>
+              </a:rPr>
+              <a:t>→ GAia plugs in, nothing is rebuilt</a:t>
+            </a:r>
+          </a:p>
+        </p:txBody>
+      </p:sp>
+      <p:sp>
+        <p:nvSpPr>
+          <p:cNvPr id="44" name="WHY GAia IS INEVITABLE"/>
+          <p:cNvSpPr/>
+          <p:nvPr/>
+        </p:nvSpPr>
+        <p:spPr>
+          <a:xfrm>
+            <a:off x="254000" y="6261100"/>
+            <a:ext cx="1905000" cy="342900"/>
+          </a:xfrm>
+          <a:prstGeom prst="rect">
+            <a:avLst/>
+          </a:prstGeom>
+          <a:noFill/>
+          <a:ln>
+            <a:noFill/>
+          </a:ln>
+          <a:effectLst/>
+        </p:spPr>
+        <p:style>
+          <a:lnRef idx="1">
+            <a:schemeClr val="accent1"/>
+          </a:lnRef>
+          <a:fillRef idx="3">
+            <a:schemeClr val="accent1"/>
+          </a:fillRef>
+          <a:effectRef idx="2">
+            <a:schemeClr val="accent1"/>
+          </a:effectRef>
+          <a:fontRef idx="minor">
+            <a:schemeClr val="lt1"/>
+          </a:fontRef>
+        </p:style>
+        <p:txBody>
+          <a:bodyPr rtlCol="0" anchor="ctr" wrap="square" lIns="0" rIns="0" tIns="12700" bIns="12700"/>
+          <a:lstStyle/>
+          <a:p>
+            <a:pPr algn="l">
+              <a:lnSpc>
+                <a:spcPct val="100000"/>
+              </a:lnSpc>
+            </a:pPr>
+            <a:r>
+              <a:rPr sz="700" b="1" spc="100">
+                <a:solidFill>
+                  <a:srgbClr val="183349"/>
+                </a:solidFill>
+                <a:latin typeface="Arial"/>
+              </a:rPr>
+              <a:t>WHY GAia IS INEVITABLE</a:t>
+            </a:r>
+          </a:p>
+        </p:txBody>
+      </p:sp>
+      <p:sp>
+        <p:nvSpPr>
+          <p:cNvPr id="45" name="✓ Raw materials"/>
+          <p:cNvSpPr/>
+          <p:nvPr/>
+        </p:nvSpPr>
+        <p:spPr>
+          <a:xfrm>
+            <a:off x="1841500" y="6311900"/>
+            <a:ext cx="952500" cy="241300"/>
+          </a:xfrm>
+          <a:prstGeom prst="roundRect">
+            <a:avLst>
+              <a:gd name="adj" fmla="val 50000"/>
+            </a:avLst>
+          </a:prstGeom>
+          <a:solidFill>
+            <a:srgbClr val="FFFFFF"/>
+          </a:solidFill>
+          <a:ln w="9525">
+            <a:solidFill>
+              <a:srgbClr val="1F7A5A"/>
+            </a:solidFill>
+          </a:ln>
+          <a:effectLst/>
+        </p:spPr>
+        <p:style>
+          <a:lnRef idx="1">
+            <a:schemeClr val="accent1"/>
+          </a:lnRef>
+          <a:fillRef idx="3">
+            <a:schemeClr val="accent1"/>
+          </a:fillRef>
+          <a:effectRef idx="2">
+            <a:schemeClr val="accent1"/>
+          </a:effectRef>
+          <a:fontRef idx="minor">
+            <a:schemeClr val="lt1"/>
+          </a:fontRef>
+        </p:style>
+        <p:txBody>
+          <a:bodyPr rtlCol="0" anchor="ctr" wrap="square" lIns="25400" rIns="25400" tIns="12700" bIns="12700"/>
+          <a:lstStyle/>
+          <a:p>
+            <a:pPr algn="ctr">
+              <a:lnSpc>
+                <a:spcPct val="100000"/>
+              </a:lnSpc>
+            </a:pPr>
+            <a:r>
+              <a:rPr sz="700" b="1">
+                <a:solidFill>
+                  <a:srgbClr val="1F7A5A"/>
+                </a:solidFill>
+                <a:latin typeface="Arial"/>
+              </a:rPr>
+              <a:t>✓ Raw materials</a:t>
+            </a:r>
+          </a:p>
+        </p:txBody>
+      </p:sp>
+      <p:sp>
+        <p:nvSpPr>
+          <p:cNvPr id="46" name="✓ Production"/>
+          <p:cNvSpPr/>
+          <p:nvPr/>
+        </p:nvSpPr>
+        <p:spPr>
+          <a:xfrm>
+            <a:off x="2857500" y="6311900"/>
+            <a:ext cx="952500" cy="241300"/>
+          </a:xfrm>
+          <a:prstGeom prst="roundRect">
+            <a:avLst>
+              <a:gd name="adj" fmla="val 50000"/>
+            </a:avLst>
+          </a:prstGeom>
+          <a:solidFill>
+            <a:srgbClr val="FFFFFF"/>
+          </a:solidFill>
+          <a:ln w="9525">
+            <a:solidFill>
+              <a:srgbClr val="1F7A5A"/>
+            </a:solidFill>
+          </a:ln>
+          <a:effectLst/>
+        </p:spPr>
+        <p:style>
+          <a:lnRef idx="1">
+            <a:schemeClr val="accent1"/>
+          </a:lnRef>
+          <a:fillRef idx="3">
+            <a:schemeClr val="accent1"/>
+          </a:fillRef>
+          <a:effectRef idx="2">
+            <a:schemeClr val="accent1"/>
+          </a:effectRef>
+          <a:fontRef idx="minor">
+            <a:schemeClr val="lt1"/>
+          </a:fontRef>
+        </p:style>
+        <p:txBody>
+          <a:bodyPr rtlCol="0" anchor="ctr" wrap="square" lIns="25400" rIns="25400" tIns="12700" bIns="12700"/>
+          <a:lstStyle/>
+          <a:p>
+            <a:pPr algn="ctr">
+              <a:lnSpc>
+                <a:spcPct val="100000"/>
+              </a:lnSpc>
+            </a:pPr>
+            <a:r>
+              <a:rPr sz="700" b="1">
+                <a:solidFill>
+                  <a:srgbClr val="1F7A5A"/>
+                </a:solidFill>
+                <a:latin typeface="Arial"/>
+              </a:rPr>
+              <a:t>✓ Production</a:t>
+            </a:r>
+          </a:p>
+        </p:txBody>
+      </p:sp>
+      <p:sp>
+        <p:nvSpPr>
+          <p:cNvPr id="47" name="✓ Storage"/>
+          <p:cNvSpPr/>
+          <p:nvPr/>
+        </p:nvSpPr>
+        <p:spPr>
+          <a:xfrm>
+            <a:off x="3873500" y="6311900"/>
+            <a:ext cx="952500" cy="241300"/>
+          </a:xfrm>
+          <a:prstGeom prst="roundRect">
+            <a:avLst>
+              <a:gd name="adj" fmla="val 50000"/>
+            </a:avLst>
+          </a:prstGeom>
+          <a:solidFill>
+            <a:srgbClr val="FFFFFF"/>
+          </a:solidFill>
+          <a:ln w="9525">
+            <a:solidFill>
+              <a:srgbClr val="1F7A5A"/>
+            </a:solidFill>
+          </a:ln>
+          <a:effectLst/>
+        </p:spPr>
+        <p:style>
+          <a:lnRef idx="1">
+            <a:schemeClr val="accent1"/>
+          </a:lnRef>
+          <a:fillRef idx="3">
+            <a:schemeClr val="accent1"/>
+          </a:fillRef>
+          <a:effectRef idx="2">
+            <a:schemeClr val="accent1"/>
+          </a:effectRef>
+          <a:fontRef idx="minor">
+            <a:schemeClr val="lt1"/>
+          </a:fontRef>
+        </p:style>
+        <p:txBody>
+          <a:bodyPr rtlCol="0" anchor="ctr" wrap="square" lIns="25400" rIns="25400" tIns="12700" bIns="12700"/>
+          <a:lstStyle/>
+          <a:p>
+            <a:pPr algn="ctr">
+              <a:lnSpc>
+                <a:spcPct val="100000"/>
+              </a:lnSpc>
+            </a:pPr>
+            <a:r>
+              <a:rPr sz="700" b="1">
+                <a:solidFill>
+                  <a:srgbClr val="1F7A5A"/>
+                </a:solidFill>
+                <a:latin typeface="Arial"/>
+              </a:rPr>
+              <a:t>✓ Storage</a:t>
+            </a:r>
+          </a:p>
+        </p:txBody>
+      </p:sp>
+      <p:sp>
+        <p:nvSpPr>
+          <p:cNvPr id="48" name="✓ Logistics"/>
+          <p:cNvSpPr/>
+          <p:nvPr/>
+        </p:nvSpPr>
+        <p:spPr>
+          <a:xfrm>
+            <a:off x="4889500" y="6311900"/>
+            <a:ext cx="952500" cy="241300"/>
+          </a:xfrm>
+          <a:prstGeom prst="roundRect">
+            <a:avLst>
+              <a:gd name="adj" fmla="val 50000"/>
+            </a:avLst>
+          </a:prstGeom>
+          <a:solidFill>
+            <a:srgbClr val="FFFFFF"/>
+          </a:solidFill>
+          <a:ln w="9525">
+            <a:solidFill>
+              <a:srgbClr val="1F7A5A"/>
+            </a:solidFill>
+          </a:ln>
+          <a:effectLst/>
+        </p:spPr>
+        <p:style>
+          <a:lnRef idx="1">
+            <a:schemeClr val="accent1"/>
+          </a:lnRef>
+          <a:fillRef idx="3">
+            <a:schemeClr val="accent1"/>
+          </a:fillRef>
+          <a:effectRef idx="2">
+            <a:schemeClr val="accent1"/>
+          </a:effectRef>
+          <a:fontRef idx="minor">
+            <a:schemeClr val="lt1"/>
+          </a:fontRef>
+        </p:style>
+        <p:txBody>
+          <a:bodyPr rtlCol="0" anchor="ctr" wrap="square" lIns="25400" rIns="25400" tIns="12700" bIns="12700"/>
+          <a:lstStyle/>
+          <a:p>
+            <a:pPr algn="ctr">
+              <a:lnSpc>
+                <a:spcPct val="100000"/>
+              </a:lnSpc>
+            </a:pPr>
+            <a:r>
+              <a:rPr sz="700" b="1">
+                <a:solidFill>
+                  <a:srgbClr val="1F7A5A"/>
+                </a:solidFill>
+                <a:latin typeface="Arial"/>
+              </a:rPr>
+              <a:t>✓ Logistics</a:t>
+            </a:r>
+          </a:p>
+        </p:txBody>
+      </p:sp>
+      <p:sp>
+        <p:nvSpPr>
+          <p:cNvPr id="49" name="✓ Market reach"/>
+          <p:cNvSpPr/>
+          <p:nvPr/>
+        </p:nvSpPr>
+        <p:spPr>
+          <a:xfrm>
+            <a:off x="5905500" y="6311900"/>
+            <a:ext cx="952500" cy="241300"/>
+          </a:xfrm>
+          <a:prstGeom prst="roundRect">
+            <a:avLst>
+              <a:gd name="adj" fmla="val 50000"/>
+            </a:avLst>
+          </a:prstGeom>
+          <a:solidFill>
+            <a:srgbClr val="FFFFFF"/>
+          </a:solidFill>
+          <a:ln w="9525">
+            <a:solidFill>
+              <a:srgbClr val="1F7A5A"/>
+            </a:solidFill>
+          </a:ln>
+          <a:effectLst/>
+        </p:spPr>
+        <p:style>
+          <a:lnRef idx="1">
+            <a:schemeClr val="accent1"/>
+          </a:lnRef>
+          <a:fillRef idx="3">
+            <a:schemeClr val="accent1"/>
+          </a:fillRef>
+          <a:effectRef idx="2">
+            <a:schemeClr val="accent1"/>
+          </a:effectRef>
+          <a:fontRef idx="minor">
+            <a:schemeClr val="lt1"/>
+          </a:fontRef>
+        </p:style>
+        <p:txBody>
+          <a:bodyPr rtlCol="0" anchor="ctr" wrap="square" lIns="25400" rIns="25400" tIns="12700" bIns="12700"/>
+          <a:lstStyle/>
+          <a:p>
+            <a:pPr algn="ctr">
+              <a:lnSpc>
+                <a:spcPct val="100000"/>
+              </a:lnSpc>
+            </a:pPr>
+            <a:r>
+              <a:rPr sz="700" b="1">
+                <a:solidFill>
+                  <a:srgbClr val="1F7A5A"/>
+                </a:solidFill>
+                <a:latin typeface="Arial"/>
+              </a:rPr>
+              <a:t>✓ Market reach</a:t>
+            </a:r>
+          </a:p>
+        </p:txBody>
+      </p:sp>
+      <p:sp>
+        <p:nvSpPr>
+          <p:cNvPr id="50" name="✗ Farmer data"/>
+          <p:cNvSpPr/>
+          <p:nvPr/>
+        </p:nvSpPr>
+        <p:spPr>
+          <a:xfrm>
+            <a:off x="6921500" y="6311900"/>
+            <a:ext cx="952500" cy="241300"/>
+          </a:xfrm>
+          <a:prstGeom prst="roundRect">
+            <a:avLst>
+              <a:gd name="adj" fmla="val 50000"/>
+            </a:avLst>
+          </a:prstGeom>
+          <a:solidFill>
+            <a:srgbClr val="B23A3A"/>
+          </a:solidFill>
+          <a:ln w="9525">
+            <a:solidFill>
+              <a:srgbClr val="B23A3A"/>
+            </a:solidFill>
+          </a:ln>
+          <a:effectLst/>
+        </p:spPr>
+        <p:style>
+          <a:lnRef idx="1">
+            <a:schemeClr val="accent1"/>
+          </a:lnRef>
+          <a:fillRef idx="3">
+            <a:schemeClr val="accent1"/>
+          </a:fillRef>
+          <a:effectRef idx="2">
+            <a:schemeClr val="accent1"/>
+          </a:effectRef>
+          <a:fontRef idx="minor">
+            <a:schemeClr val="lt1"/>
+          </a:fontRef>
+        </p:style>
+        <p:txBody>
+          <a:bodyPr rtlCol="0" anchor="ctr" wrap="square" lIns="25400" rIns="25400" tIns="12700" bIns="12700"/>
+          <a:lstStyle/>
+          <a:p>
+            <a:pPr algn="ctr">
+              <a:lnSpc>
+                <a:spcPct val="100000"/>
+              </a:lnSpc>
+            </a:pPr>
+            <a:r>
+              <a:rPr sz="700" b="1">
+                <a:solidFill>
+                  <a:srgbClr val="FFFFFF"/>
+                </a:solidFill>
+                <a:latin typeface="Arial"/>
+              </a:rPr>
+              <a:t>✗ Farmer data</a:t>
+            </a:r>
+          </a:p>
+        </p:txBody>
+      </p:sp>
+      <p:sp>
+        <p:nvSpPr>
+          <p:cNvPr id="51" name="THE INVITATION:  co-build the digital"/>
+          <p:cNvSpPr/>
+          <p:nvPr/>
+        </p:nvSpPr>
+        <p:spPr>
+          <a:xfrm>
+            <a:off x="8001000" y="6261100"/>
+            <a:ext cx="3937000" cy="342900"/>
+          </a:xfrm>
+          <a:prstGeom prst="roundRect">
+            <a:avLst>
+              <a:gd name="adj" fmla="val 12000"/>
+            </a:avLst>
+          </a:prstGeom>
+          <a:solidFill>
+            <a:srgbClr val="FFFFFF"/>
+          </a:solidFill>
+          <a:ln w="19050">
+            <a:solidFill>
+              <a:srgbClr val="183349"/>
+            </a:solidFill>
+          </a:ln>
+          <a:effectLst/>
+        </p:spPr>
+        <p:style>
+          <a:lnRef idx="1">
+            <a:schemeClr val="accent1"/>
+          </a:lnRef>
+          <a:fillRef idx="3">
+            <a:schemeClr val="accent1"/>
+          </a:fillRef>
+          <a:effectRef idx="2">
+            <a:schemeClr val="accent1"/>
+          </a:effectRef>
+          <a:fontRef idx="minor">
+            <a:schemeClr val="lt1"/>
+          </a:fontRef>
+        </p:style>
+        <p:txBody>
+          <a:bodyPr rtlCol="0" anchor="ctr" wrap="square" lIns="101600" rIns="101600" tIns="12700" bIns="12700"/>
+          <a:lstStyle/>
+          <a:p>
+            <a:pPr algn="l">
+              <a:lnSpc>
+                <a:spcPct val="100000"/>
+              </a:lnSpc>
+            </a:pPr>
+            <a:r>
+              <a:rPr sz="700" b="1">
+                <a:solidFill>
+                  <a:srgbClr val="183349"/>
+                </a:solidFill>
+                <a:latin typeface="Arial"/>
+              </a:rPr>
+              <a:t>THE INVITATION:</a:t>
+            </a:r>
+            <a:r>
+              <a:rPr sz="700" b="0">
+                <a:solidFill>
+                  <a:srgbClr val="183349"/>
+                </a:solidFill>
+                <a:latin typeface="Arial"/>
+              </a:rPr>
+              <a:t> co-build the digital layer on top of Europe's #2 fertilizer network. The physical scale is already there.</a:t>
+            </a:r>
+          </a:p>
+        </p:txBody>
+      </p:sp>
+      <p:sp>
+        <p:nvSpPr>
+          <p:cNvPr id="52" name="Sources: Grupa Azoty Strategy 2030, Fert"/>
+          <p:cNvSpPr/>
+          <p:nvPr/>
+        </p:nvSpPr>
+        <p:spPr>
+          <a:xfrm>
+            <a:off x="254000" y="6642100"/>
+            <a:ext cx="11684000" cy="114300"/>
+          </a:xfrm>
+          <a:prstGeom prst="rect">
+            <a:avLst/>
+          </a:prstGeom>
+          <a:noFill/>
+          <a:ln>
+            <a:noFill/>
+          </a:ln>
+          <a:effectLst/>
+        </p:spPr>
+        <p:style>
+          <a:lnRef idx="1">
+            <a:schemeClr val="accent1"/>
+          </a:lnRef>
+          <a:fillRef idx="3">
+            <a:schemeClr val="accent1"/>
+          </a:fillRef>
+          <a:effectRef idx="2">
+            <a:schemeClr val="accent1"/>
+          </a:effectRef>
+          <a:fontRef idx="minor">
+            <a:schemeClr val="lt1"/>
+          </a:fontRef>
+        </p:style>
+        <p:txBody>
+          <a:bodyPr rtlCol="0" anchor="ctr" wrap="square" lIns="0" rIns="0" tIns="12700" bIns="12700"/>
+          <a:lstStyle/>
+          <a:p>
+            <a:pPr algn="l">
+              <a:lnSpc>
+                <a:spcPct val="100000"/>
+              </a:lnSpc>
+            </a:pPr>
+            <a:r>
+              <a:rPr sz="550" b="0">
+                <a:solidFill>
+                  <a:srgbClr val="5B6B76"/>
+                </a:solidFill>
+                <a:latin typeface="Arial"/>
+              </a:rPr>
+              <a:t>Sources: Grupa Azoty Strategy 2030, Fertilizer Strategy, integrated system map. Revenue upside is an internal estimate, to be validated in a 90-day pilot.</a:t>
+            </a:r>
+          </a:p>
+        </p:txBody>
+      </p:sp>
+      <p:cxnSp>
+        <p:nvCxnSpPr>
+          <p:cNvPr id="53" name="Arrow"/>
+          <p:cNvCxnSpPr/>
+          <p:nvPr/>
+        </p:nvCxnSpPr>
+        <p:spPr>
+          <a:xfrm>
+            <a:off x="2286000" y="1625600"/>
+            <a:ext cx="476250" cy="0"/>
+          </a:xfrm>
+          <a:prstGeom prst="line">
+            <a:avLst/>
+          </a:prstGeom>
+          <a:ln w="47625">
+            <a:solidFill>
+              <a:srgbClr val="183349"/>
+            </a:solidFill>
+            <a:tailEnd type="triangle" w="med" len="med"/>
+          </a:ln>
+        </p:spPr>
+        <p:style>
+          <a:lnRef idx="2">
+            <a:schemeClr val="accent1"/>
+          </a:lnRef>
+          <a:fillRef idx="0">
+            <a:schemeClr val="accent1"/>
+          </a:fillRef>
+          <a:effectRef idx="1">
+            <a:schemeClr val="accent1"/>
+          </a:effectRef>
+          <a:fontRef idx="minor">
+            <a:schemeClr val="tx1"/>
+          </a:fontRef>
+        </p:style>
+      </p:cxnSp>
+      <p:cxnSp>
+        <p:nvCxnSpPr>
+          <p:cNvPr id="54" name="Arrow"/>
+          <p:cNvCxnSpPr/>
+          <p:nvPr/>
+        </p:nvCxnSpPr>
+        <p:spPr>
+          <a:xfrm>
+            <a:off x="4667250" y="1625600"/>
+            <a:ext cx="476250" cy="0"/>
+          </a:xfrm>
+          <a:prstGeom prst="line">
+            <a:avLst/>
+          </a:prstGeom>
+          <a:ln w="47625">
+            <a:solidFill>
+              <a:srgbClr val="183349"/>
+            </a:solidFill>
+            <a:tailEnd type="triangle" w="med" len="med"/>
+          </a:ln>
+        </p:spPr>
+        <p:style>
+          <a:lnRef idx="2">
+            <a:schemeClr val="accent1"/>
+          </a:lnRef>
+          <a:fillRef idx="0">
+            <a:schemeClr val="accent1"/>
+          </a:fillRef>
+          <a:effectRef idx="1">
+            <a:schemeClr val="accent1"/>
+          </a:effectRef>
+          <a:fontRef idx="minor">
+            <a:schemeClr val="tx1"/>
+          </a:fontRef>
+        </p:style>
+      </p:cxnSp>
+      <p:cxnSp>
+        <p:nvCxnSpPr>
+          <p:cNvPr id="55" name="Arrow"/>
+          <p:cNvCxnSpPr/>
+          <p:nvPr/>
+        </p:nvCxnSpPr>
+        <p:spPr>
+          <a:xfrm>
+            <a:off x="7048500" y="1625600"/>
+            <a:ext cx="476250" cy="0"/>
+          </a:xfrm>
+          <a:prstGeom prst="line">
+            <a:avLst/>
+          </a:prstGeom>
+          <a:ln w="47625">
+            <a:solidFill>
+              <a:srgbClr val="183349"/>
+            </a:solidFill>
+            <a:tailEnd type="triangle" w="med" len="med"/>
+          </a:ln>
+        </p:spPr>
+        <p:style>
+          <a:lnRef idx="2">
+            <a:schemeClr val="accent1"/>
+          </a:lnRef>
+          <a:fillRef idx="0">
+            <a:schemeClr val="accent1"/>
+          </a:fillRef>
+          <a:effectRef idx="1">
+            <a:schemeClr val="accent1"/>
+          </a:effectRef>
+          <a:fontRef idx="minor">
+            <a:schemeClr val="tx1"/>
+          </a:fontRef>
+        </p:style>
+      </p:cxnSp>
+      <p:cxnSp>
+        <p:nvCxnSpPr>
+          <p:cNvPr id="56" name="Arrow"/>
+          <p:cNvCxnSpPr/>
+          <p:nvPr/>
+        </p:nvCxnSpPr>
+        <p:spPr>
+          <a:xfrm>
+            <a:off x="9429750" y="1625600"/>
+            <a:ext cx="476250" cy="0"/>
+          </a:xfrm>
+          <a:prstGeom prst="line">
+            <a:avLst/>
+          </a:prstGeom>
+          <a:ln w="47625">
+            <a:solidFill>
+              <a:srgbClr val="183349"/>
+            </a:solidFill>
+            <a:tailEnd type="triangle" w="med" len="med"/>
+          </a:ln>
+        </p:spPr>
+        <p:style>
+          <a:lnRef idx="2">
+            <a:schemeClr val="accent1"/>
+          </a:lnRef>
+          <a:fillRef idx="0">
+            <a:schemeClr val="accent1"/>
+          </a:fillRef>
+          <a:effectRef idx="1">
+            <a:schemeClr val="accent1"/>
+          </a:effectRef>
+          <a:fontRef idx="minor">
+            <a:schemeClr val="tx1"/>
+          </a:fontRef>
+        </p:style>
+      </p:cxnSp>
+      <p:cxnSp>
+        <p:nvCxnSpPr>
+          <p:cNvPr id="57" name="Arrow"/>
+          <p:cNvCxnSpPr/>
+          <p:nvPr/>
+        </p:nvCxnSpPr>
+        <p:spPr>
+          <a:xfrm>
+            <a:off x="2286000" y="3060700"/>
+            <a:ext cx="238125" cy="0"/>
+          </a:xfrm>
+          <a:prstGeom prst="line">
+            <a:avLst/>
+          </a:prstGeom>
+          <a:ln w="19050">
+            <a:solidFill>
+              <a:srgbClr val="1F5F99"/>
+            </a:solidFill>
+            <a:prstDash val="dash"/>
+          </a:ln>
+        </p:spPr>
+        <p:style>
+          <a:lnRef idx="2">
+            <a:schemeClr val="accent1"/>
+          </a:lnRef>
+          <a:fillRef idx="0">
+            <a:schemeClr val="accent1"/>
+          </a:fillRef>
+          <a:effectRef idx="1">
+            <a:schemeClr val="accent1"/>
+          </a:effectRef>
+          <a:fontRef idx="minor">
+            <a:schemeClr val="tx1"/>
+          </a:fontRef>
+        </p:style>
+      </p:cxnSp>
+      <p:cxnSp>
+        <p:nvCxnSpPr>
+          <p:cNvPr id="58" name="Arrow"/>
+          <p:cNvCxnSpPr/>
+          <p:nvPr/>
+        </p:nvCxnSpPr>
+        <p:spPr>
+          <a:xfrm flipV="1">
+            <a:off x="2524125" y="2247900"/>
+            <a:ext cx="0" cy="812800"/>
+          </a:xfrm>
+          <a:prstGeom prst="line">
+            <a:avLst/>
+          </a:prstGeom>
+          <a:ln w="19050">
+            <a:solidFill>
+              <a:srgbClr val="1F5F99"/>
+            </a:solidFill>
+            <a:prstDash val="dash"/>
+          </a:ln>
+        </p:spPr>
+        <p:style>
+          <a:lnRef idx="2">
+            <a:schemeClr val="accent1"/>
+          </a:lnRef>
+          <a:fillRef idx="0">
+            <a:schemeClr val="accent1"/>
+          </a:fillRef>
+          <a:effectRef idx="1">
+            <a:schemeClr val="accent1"/>
+          </a:effectRef>
+          <a:fontRef idx="minor">
+            <a:schemeClr val="tx1"/>
+          </a:fontRef>
+        </p:style>
+      </p:cxnSp>
+      <p:cxnSp>
+        <p:nvCxnSpPr>
+          <p:cNvPr id="59" name="Arrow"/>
+          <p:cNvCxnSpPr/>
+          <p:nvPr/>
+        </p:nvCxnSpPr>
+        <p:spPr>
+          <a:xfrm>
+            <a:off x="2524125" y="2247900"/>
+            <a:ext cx="238125" cy="0"/>
+          </a:xfrm>
+          <a:prstGeom prst="line">
+            <a:avLst/>
+          </a:prstGeom>
+          <a:ln w="19050">
+            <a:solidFill>
+              <a:srgbClr val="1F5F99"/>
+            </a:solidFill>
+            <a:prstDash val="dash"/>
+            <a:tailEnd type="triangle" w="med" len="med"/>
+          </a:ln>
+        </p:spPr>
+        <p:style>
+          <a:lnRef idx="2">
+            <a:schemeClr val="accent1"/>
+          </a:lnRef>
+          <a:fillRef idx="0">
+            <a:schemeClr val="accent1"/>
+          </a:fillRef>
+          <a:effectRef idx="1">
+            <a:schemeClr val="accent1"/>
+          </a:effectRef>
+          <a:fontRef idx="minor">
+            <a:schemeClr val="tx1"/>
+          </a:fontRef>
+        </p:style>
+      </p:cxnSp>
+      <p:sp>
+        <p:nvSpPr>
+          <p:cNvPr id="60" name="Arrow label"/>
+          <p:cNvSpPr/>
+          <p:nvPr/>
+        </p:nvSpPr>
+        <p:spPr>
+          <a:xfrm>
+            <a:off x="2320925" y="2546350"/>
+            <a:ext cx="406400" cy="215900"/>
+          </a:xfrm>
+          <a:prstGeom prst="rect">
+            <a:avLst/>
+          </a:prstGeom>
+          <a:solidFill>
+            <a:srgbClr val="F3F4F5"/>
+          </a:solidFill>
+          <a:ln>
+            <a:noFill/>
+          </a:ln>
+          <a:effectLst/>
+        </p:spPr>
+        <p:style>
+          <a:lnRef idx="1">
+            <a:schemeClr val="accent1"/>
+          </a:lnRef>
+          <a:fillRef idx="3">
+            <a:schemeClr val="accent1"/>
+          </a:fillRef>
+          <a:effectRef idx="2">
+            <a:schemeClr val="accent1"/>
+          </a:effectRef>
+          <a:fontRef idx="minor">
+            <a:schemeClr val="lt1"/>
+          </a:fontRef>
+        </p:style>
+        <p:txBody>
+          <a:bodyPr rtlCol="0" anchor="ctr" wrap="square" lIns="12700" rIns="12700" tIns="12700" bIns="12700"/>
+          <a:lstStyle/>
+          <a:p>
+            <a:pPr algn="ctr">
+              <a:lnSpc>
+                <a:spcPct val="100000"/>
+              </a:lnSpc>
+            </a:pPr>
+            <a:r>
+              <a:rPr sz="550" b="1">
+                <a:solidFill>
+                  <a:srgbClr val="1F5F99"/>
+                </a:solidFill>
+                <a:latin typeface="Arial"/>
+              </a:rPr>
+              <a:t>NH₃ by</a:t>
+            </a:r>
+          </a:p>
+          <a:p>
+            <a:pPr algn="ctr">
+              <a:lnSpc>
+                <a:spcPct val="100000"/>
+              </a:lnSpc>
+            </a:pPr>
+            <a:r>
+              <a:rPr sz="550" b="1">
+                <a:solidFill>
+                  <a:srgbClr val="1F5F99"/>
+                </a:solidFill>
+                <a:latin typeface="Arial"/>
+              </a:rPr>
+              <a:t>own rail</a:t>
+            </a:r>
+          </a:p>
+        </p:txBody>
+      </p:sp>
+      <p:cxnSp>
+        <p:nvCxnSpPr>
+          <p:cNvPr id="61" name="Arrow"/>
+          <p:cNvCxnSpPr/>
+          <p:nvPr/>
+        </p:nvCxnSpPr>
+        <p:spPr>
+          <a:xfrm flipH="1">
+            <a:off x="9842500" y="5219700"/>
+            <a:ext cx="381000" cy="0"/>
+          </a:xfrm>
+          <a:prstGeom prst="line">
+            <a:avLst/>
+          </a:prstGeom>
+          <a:ln w="28575">
+            <a:solidFill>
+              <a:srgbClr val="1F7A5A"/>
+            </a:solidFill>
+            <a:tailEnd type="triangle" w="med" len="med"/>
+          </a:ln>
+        </p:spPr>
+        <p:style>
+          <a:lnRef idx="2">
+            <a:schemeClr val="accent1"/>
+          </a:lnRef>
+          <a:fillRef idx="0">
+            <a:schemeClr val="accent1"/>
+          </a:fillRef>
+          <a:effectRef idx="1">
+            <a:schemeClr val="accent1"/>
+          </a:effectRef>
+          <a:fontRef idx="minor">
+            <a:schemeClr val="tx1"/>
+          </a:fontRef>
+        </p:style>
+      </p:cxnSp>
+      <p:cxnSp>
+        <p:nvCxnSpPr>
+          <p:cNvPr id="62" name="Arrow"/>
+          <p:cNvCxnSpPr/>
+          <p:nvPr/>
+        </p:nvCxnSpPr>
+        <p:spPr>
+          <a:xfrm flipH="1">
+            <a:off x="7874000" y="5219700"/>
+            <a:ext cx="381000" cy="0"/>
+          </a:xfrm>
+          <a:prstGeom prst="line">
+            <a:avLst/>
+          </a:prstGeom>
+          <a:ln w="28575">
+            <a:solidFill>
+              <a:srgbClr val="1F7A5A"/>
+            </a:solidFill>
+            <a:tailEnd type="triangle" w="med" len="med"/>
+          </a:ln>
+        </p:spPr>
+        <p:style>
+          <a:lnRef idx="2">
+            <a:schemeClr val="accent1"/>
+          </a:lnRef>
+          <a:fillRef idx="0">
+            <a:schemeClr val="accent1"/>
+          </a:fillRef>
+          <a:effectRef idx="1">
+            <a:schemeClr val="accent1"/>
+          </a:effectRef>
+          <a:fontRef idx="minor">
+            <a:schemeClr val="tx1"/>
+          </a:fontRef>
+        </p:style>
+      </p:cxnSp>
+      <p:cxnSp>
+        <p:nvCxnSpPr>
+          <p:cNvPr id="63" name="Arrow"/>
+          <p:cNvCxnSpPr/>
+          <p:nvPr/>
+        </p:nvCxnSpPr>
+        <p:spPr>
+          <a:xfrm flipH="1">
+            <a:off x="5905500" y="5219700"/>
+            <a:ext cx="381000" cy="0"/>
+          </a:xfrm>
+          <a:prstGeom prst="line">
+            <a:avLst/>
+          </a:prstGeom>
+          <a:ln w="28575">
+            <a:solidFill>
+              <a:srgbClr val="1F7A5A"/>
+            </a:solidFill>
+            <a:tailEnd type="triangle" w="med" len="med"/>
+          </a:ln>
+        </p:spPr>
+        <p:style>
+          <a:lnRef idx="2">
+            <a:schemeClr val="accent1"/>
+          </a:lnRef>
+          <a:fillRef idx="0">
+            <a:schemeClr val="accent1"/>
+          </a:fillRef>
+          <a:effectRef idx="1">
+            <a:schemeClr val="accent1"/>
+          </a:effectRef>
+          <a:fontRef idx="minor">
+            <a:schemeClr val="tx1"/>
+          </a:fontRef>
+        </p:style>
+      </p:cxnSp>
+      <p:cxnSp>
+        <p:nvCxnSpPr>
+          <p:cNvPr id="64" name="Arrow"/>
+          <p:cNvCxnSpPr/>
+          <p:nvPr/>
+        </p:nvCxnSpPr>
+        <p:spPr>
+          <a:xfrm flipH="1">
+            <a:off x="3937000" y="5219700"/>
+            <a:ext cx="381000" cy="0"/>
+          </a:xfrm>
+          <a:prstGeom prst="line">
+            <a:avLst/>
+          </a:prstGeom>
+          <a:ln w="28575">
+            <a:solidFill>
+              <a:srgbClr val="1F7A5A"/>
+            </a:solidFill>
+            <a:tailEnd type="triangle" w="med" len="med"/>
+          </a:ln>
+        </p:spPr>
+        <p:style>
+          <a:lnRef idx="2">
+            <a:schemeClr val="accent1"/>
+          </a:lnRef>
+          <a:fillRef idx="0">
+            <a:schemeClr val="accent1"/>
+          </a:fillRef>
+          <a:effectRef idx="1">
+            <a:schemeClr val="accent1"/>
+          </a:effectRef>
+          <a:fontRef idx="minor">
+            <a:schemeClr val="tx1"/>
+          </a:fontRef>
+        </p:style>
+      </p:cxnSp>
+      <p:cxnSp>
+        <p:nvCxnSpPr>
+          <p:cNvPr id="65" name="Arrow"/>
+          <p:cNvCxnSpPr/>
+          <p:nvPr/>
+        </p:nvCxnSpPr>
+        <p:spPr>
+          <a:xfrm flipH="1">
+            <a:off x="1968500" y="5219700"/>
+            <a:ext cx="381000" cy="0"/>
+          </a:xfrm>
+          <a:prstGeom prst="line">
+            <a:avLst/>
+          </a:prstGeom>
+          <a:ln w="28575">
+            <a:solidFill>
+              <a:srgbClr val="1F7A5A"/>
+            </a:solidFill>
+            <a:tailEnd type="triangle" w="med" len="med"/>
+          </a:ln>
+        </p:spPr>
+        <p:style>
+          <a:lnRef idx="2">
+            <a:schemeClr val="accent1"/>
+          </a:lnRef>
+          <a:fillRef idx="0">
+            <a:schemeClr val="accent1"/>
+          </a:fillRef>
+          <a:effectRef idx="1">
+            <a:schemeClr val="accent1"/>
+          </a:effectRef>
+          <a:fontRef idx="minor">
+            <a:schemeClr val="tx1"/>
+          </a:fontRef>
+        </p:style>
+      </p:cxnSp>
+      <p:cxnSp>
+        <p:nvCxnSpPr>
+          <p:cNvPr id="66" name="Arrow"/>
+          <p:cNvCxnSpPr/>
+          <p:nvPr/>
+        </p:nvCxnSpPr>
+        <p:spPr>
+          <a:xfrm>
+            <a:off x="10858500" y="3238500"/>
+            <a:ext cx="0" cy="1612900"/>
+          </a:xfrm>
+          <a:prstGeom prst="line">
+            <a:avLst/>
+          </a:prstGeom>
+          <a:ln w="28575">
+            <a:solidFill>
+              <a:srgbClr val="1F7A5A"/>
+            </a:solidFill>
+            <a:tailEnd type="triangle" w="med" len="med"/>
+          </a:ln>
+        </p:spPr>
+        <p:style>
+          <a:lnRef idx="2">
+            <a:schemeClr val="accent1"/>
+          </a:lnRef>
+          <a:fillRef idx="0">
+            <a:schemeClr val="accent1"/>
+          </a:fillRef>
+          <a:effectRef idx="1">
+            <a:schemeClr val="accent1"/>
+          </a:effectRef>
+          <a:fontRef idx="minor">
+            <a:schemeClr val="tx1"/>
+          </a:fontRef>
+        </p:style>
+      </p:cxnSp>
+      <p:sp>
+        <p:nvSpPr>
+          <p:cNvPr id="67" name="Arrow label"/>
+          <p:cNvSpPr/>
+          <p:nvPr/>
+        </p:nvSpPr>
+        <p:spPr>
+          <a:xfrm>
+            <a:off x="10033000" y="3968750"/>
+            <a:ext cx="1651000" cy="152400"/>
+          </a:xfrm>
+          <a:prstGeom prst="rect">
+            <a:avLst/>
+          </a:prstGeom>
+          <a:solidFill>
+            <a:srgbClr val="FFFFFF"/>
+          </a:solidFill>
+          <a:ln>
+            <a:noFill/>
+          </a:ln>
+          <a:effectLst/>
+        </p:spPr>
+        <p:style>
+          <a:lnRef idx="1">
+            <a:schemeClr val="accent1"/>
+          </a:lnRef>
+          <a:fillRef idx="3">
+            <a:schemeClr val="accent1"/>
+          </a:fillRef>
+          <a:effectRef idx="2">
+            <a:schemeClr val="accent1"/>
+          </a:effectRef>
+          <a:fontRef idx="minor">
+            <a:schemeClr val="lt1"/>
+          </a:fontRef>
+        </p:style>
+        <p:txBody>
+          <a:bodyPr rtlCol="0" anchor="ctr" wrap="square" lIns="12700" rIns="12700" tIns="12700" bIns="12700"/>
+          <a:lstStyle/>
+          <a:p>
+            <a:pPr algn="ctr">
+              <a:lnSpc>
+                <a:spcPct val="100000"/>
+              </a:lnSpc>
+            </a:pPr>
+            <a:r>
+              <a:rPr sz="650" b="1">
+                <a:solidFill>
+                  <a:srgbClr val="1F7A5A"/>
+                </a:solidFill>
+                <a:latin typeface="Arial"/>
+              </a:rPr>
+              <a:t>farmer demand, visible for the first time</a:t>
+            </a:r>
+          </a:p>
+        </p:txBody>
+      </p:sp>
+      <p:cxnSp>
+        <p:nvCxnSpPr>
+          <p:cNvPr id="68" name="Arrow"/>
+          <p:cNvCxnSpPr/>
+          <p:nvPr/>
+        </p:nvCxnSpPr>
+        <p:spPr>
+          <a:xfrm flipV="1">
+            <a:off x="1333500" y="4356100"/>
+            <a:ext cx="0" cy="495300"/>
+          </a:xfrm>
+          <a:prstGeom prst="line">
+            <a:avLst/>
+          </a:prstGeom>
+          <a:ln w="38100">
+            <a:solidFill>
+              <a:srgbClr val="1F7A5A"/>
+            </a:solidFill>
+          </a:ln>
+        </p:spPr>
+        <p:style>
+          <a:lnRef idx="2">
+            <a:schemeClr val="accent1"/>
+          </a:lnRef>
+          <a:fillRef idx="0">
+            <a:schemeClr val="accent1"/>
+          </a:fillRef>
+          <a:effectRef idx="1">
+            <a:schemeClr val="accent1"/>
+          </a:effectRef>
+          <a:fontRef idx="minor">
+            <a:schemeClr val="tx1"/>
+          </a:fontRef>
+        </p:style>
+      </p:cxnSp>
+      <p:cxnSp>
+        <p:nvCxnSpPr>
+          <p:cNvPr id="69" name="Arrow"/>
+          <p:cNvCxnSpPr/>
+          <p:nvPr/>
+        </p:nvCxnSpPr>
+        <p:spPr>
+          <a:xfrm flipV="1">
+            <a:off x="1333500" y="3644900"/>
+            <a:ext cx="0" cy="698500"/>
+          </a:xfrm>
+          <a:prstGeom prst="line">
+            <a:avLst/>
+          </a:prstGeom>
+          <a:ln w="28575">
+            <a:solidFill>
+              <a:srgbClr val="1F7A5A"/>
+            </a:solidFill>
+            <a:tailEnd type="triangle" w="med" len="med"/>
+          </a:ln>
+        </p:spPr>
+        <p:style>
+          <a:lnRef idx="2">
+            <a:schemeClr val="accent1"/>
+          </a:lnRef>
+          <a:fillRef idx="0">
+            <a:schemeClr val="accent1"/>
+          </a:fillRef>
+          <a:effectRef idx="1">
+            <a:schemeClr val="accent1"/>
+          </a:effectRef>
+          <a:fontRef idx="minor">
+            <a:schemeClr val="tx1"/>
+          </a:fontRef>
+        </p:style>
+      </p:cxnSp>
+      <p:cxnSp>
+        <p:nvCxnSpPr>
+          <p:cNvPr id="70" name="Arrow"/>
+          <p:cNvCxnSpPr/>
+          <p:nvPr/>
+        </p:nvCxnSpPr>
+        <p:spPr>
+          <a:xfrm flipV="1">
+            <a:off x="3714512" y="4051300"/>
+            <a:ext cx="238" cy="292100"/>
+          </a:xfrm>
+          <a:prstGeom prst="line">
+            <a:avLst/>
+          </a:prstGeom>
+          <a:ln w="28575">
+            <a:solidFill>
+              <a:srgbClr val="1F7A5A"/>
+            </a:solidFill>
+            <a:tailEnd type="triangle" w="med" len="med"/>
+          </a:ln>
+        </p:spPr>
+        <p:style>
+          <a:lnRef idx="2">
+            <a:schemeClr val="accent1"/>
+          </a:lnRef>
+          <a:fillRef idx="0">
+            <a:schemeClr val="accent1"/>
+          </a:fillRef>
+          <a:effectRef idx="1">
+            <a:schemeClr val="accent1"/>
+          </a:effectRef>
+          <a:fontRef idx="minor">
+            <a:schemeClr val="tx1"/>
+          </a:fontRef>
+        </p:style>
+      </p:cxnSp>
+      <p:cxnSp>
+        <p:nvCxnSpPr>
+          <p:cNvPr id="71" name="Arrow"/>
+          <p:cNvCxnSpPr/>
+          <p:nvPr/>
+        </p:nvCxnSpPr>
+        <p:spPr>
+          <a:xfrm flipH="1" flipV="1">
+            <a:off x="6096000" y="3644900"/>
+            <a:ext cx="238" cy="698500"/>
+          </a:xfrm>
+          <a:prstGeom prst="line">
+            <a:avLst/>
+          </a:prstGeom>
+          <a:ln w="28575">
+            <a:solidFill>
+              <a:srgbClr val="1F7A5A"/>
+            </a:solidFill>
+            <a:tailEnd type="triangle" w="med" len="med"/>
+          </a:ln>
+        </p:spPr>
+        <p:style>
+          <a:lnRef idx="2">
+            <a:schemeClr val="accent1"/>
+          </a:lnRef>
+          <a:fillRef idx="0">
+            <a:schemeClr val="accent1"/>
+          </a:fillRef>
+          <a:effectRef idx="1">
+            <a:schemeClr val="accent1"/>
+          </a:effectRef>
+          <a:fontRef idx="minor">
+            <a:schemeClr val="tx1"/>
+          </a:fontRef>
+        </p:style>
+      </p:cxnSp>
+      <p:cxnSp>
+        <p:nvCxnSpPr>
+          <p:cNvPr id="72" name="Arrow"/>
+          <p:cNvCxnSpPr/>
+          <p:nvPr/>
+        </p:nvCxnSpPr>
+        <p:spPr>
+          <a:xfrm flipV="1">
+            <a:off x="8477250" y="3238500"/>
+            <a:ext cx="0" cy="1104900"/>
+          </a:xfrm>
+          <a:prstGeom prst="line">
+            <a:avLst/>
+          </a:prstGeom>
+          <a:ln w="28575">
+            <a:solidFill>
+              <a:srgbClr val="1F7A5A"/>
+            </a:solidFill>
+            <a:tailEnd type="triangle" w="med" len="med"/>
+          </a:ln>
+        </p:spPr>
+        <p:style>
+          <a:lnRef idx="2">
+            <a:schemeClr val="accent1"/>
+          </a:lnRef>
+          <a:fillRef idx="0">
+            <a:schemeClr val="accent1"/>
+          </a:fillRef>
+          <a:effectRef idx="1">
+            <a:schemeClr val="accent1"/>
+          </a:effectRef>
+          <a:fontRef idx="minor">
+            <a:schemeClr val="tx1"/>
+          </a:fontRef>
+        </p:style>
+      </p:cxnSp>
     </p:spTree>
   </p:cSld>
   <p:clrMapOvr>

</xml_diff>